<commit_message>
Update hackathon fraud detection presentation
</commit_message>
<xml_diff>
--- a/stdbank-pip/report/FinTech_Titans_Fraud_Detection 1.pptx
+++ b/stdbank-pip/report/FinTech_Titans_Fraud_Detection 1.pptx
@@ -4,6 +4,9 @@
   <p:sldMasterIdLst>
     <p:sldMasterId id="2147483648" r:id="rId1"/>
   </p:sldMasterIdLst>
+  <p:notesMasterIdLst>
+    <p:notesMasterId r:id="rId14"/>
+  </p:notesMasterIdLst>
   <p:sldIdLst>
     <p:sldId id="256" r:id="rId2"/>
     <p:sldId id="257" r:id="rId3"/>
@@ -18,9 +21,6 @@
     <p:sldId id="266" r:id="rId12"/>
     <p:sldId id="267" r:id="rId13"/>
   </p:sldIdLst>
-  <p:notesMasterIdLst>
-    <p:notesMasterId r:id="rId14"/>
-  </p:notesMasterIdLst>
   <p:sldSz cx="12192000" cy="6858000"/>
   <p:notesSz cx="6858000" cy="12192000"/>
   <p:defaultTextStyle>
@@ -115,13 +115,20 @@
       </a:defRPr>
     </a:lvl9pPr>
   </p:defaultTextStyle>
+  <p:extLst>
+    <p:ext uri="{EFAFB233-063F-42B5-8137-9DF3F51BA10A}">
+      <p15:sldGuideLst xmlns:p15="http://schemas.microsoft.com/office/powerpoint/2012/main"/>
+    </p:ext>
+  </p:extLst>
 </p:presentation>
 </file>
 
 <file path=ppt/charts/chart1.xml><?xml version="1.0" encoding="utf-8"?>
-<c:chartSpace xmlns:c="http://schemas.openxmlformats.org/drawingml/2006/chart" xmlns:a="http://schemas.openxmlformats.org/drawingml/2006/main" xmlns:r="http://schemas.openxmlformats.org/officeDocument/2006/relationships">
+<c:chartSpace xmlns:c="http://schemas.openxmlformats.org/drawingml/2006/chart" xmlns:a="http://schemas.openxmlformats.org/drawingml/2006/main" xmlns:r="http://schemas.openxmlformats.org/officeDocument/2006/relationships" xmlns:c16r2="http://schemas.microsoft.com/office/drawing/2015/06/chart">
   <c:date1904 val="0"/>
+  <c:lang val="en-US"/>
   <c:roundedCorners val="1"/>
+  <c:style val="2"/>
   <c:chart>
     <c:autoTitleDeleted val="1"/>
     <c:plotArea>
@@ -171,6 +178,11 @@
               </a:ln>
               <a:effectLst/>
             </c:spPr>
+            <c:extLst>
+              <c:ext xmlns:c16="http://schemas.microsoft.com/office/drawing/2014/chart" uri="{C3380CC4-5D6E-409C-BE32-E72D297353CC}">
+                <c16:uniqueId val="{00000001-9FC8-4944-AA4A-9EC6112069A9}"/>
+              </c:ext>
+            </c:extLst>
           </c:dPt>
           <c:dPt>
             <c:idx val="1"/>
@@ -188,81 +200,12 @@
               </a:ln>
               <a:effectLst/>
             </c:spPr>
+            <c:extLst>
+              <c:ext xmlns:c16="http://schemas.microsoft.com/office/drawing/2014/chart" uri="{C3380CC4-5D6E-409C-BE32-E72D297353CC}">
+                <c16:uniqueId val="{00000003-9FC8-4944-AA4A-9EC6112069A9}"/>
+              </c:ext>
+            </c:extLst>
           </c:dPt>
-          <c:dLbls>
-            <c:dLbl>
-              <c:idx val="0"/>
-              <c:numFmt formatCode="General" sourceLinked="0"/>
-              <c:spPr/>
-              <c:txPr>
-                <a:bodyPr/>
-                <a:lstStyle/>
-                <a:p>
-                  <a:pPr>
-                    <a:defRPr sz="1200" b="0" i="0" u="none" strike="noStrike">
-                      <a:solidFill>
-                        <a:srgbClr val="000000"/>
-                      </a:solidFill>
-                      <a:latin typeface="Arial"/>
-                    </a:defRPr>
-                  </a:pPr>
-                </a:p>
-              </c:txPr>
-              <c:showLegendKey val="0"/>
-              <c:showVal val="0"/>
-              <c:showCatName val="0"/>
-              <c:showSerName val="0"/>
-              <c:showPercent val="0"/>
-              <c:showBubbleSize val="0"/>
-            </c:dLbl>
-            <c:dLbl>
-              <c:idx val="1"/>
-              <c:numFmt formatCode="General" sourceLinked="0"/>
-              <c:spPr/>
-              <c:txPr>
-                <a:bodyPr/>
-                <a:lstStyle/>
-                <a:p>
-                  <a:pPr>
-                    <a:defRPr sz="1200" b="0" i="0" u="none" strike="noStrike">
-                      <a:solidFill>
-                        <a:srgbClr val="000000"/>
-                      </a:solidFill>
-                      <a:latin typeface="Arial"/>
-                    </a:defRPr>
-                  </a:pPr>
-                </a:p>
-              </c:txPr>
-              <c:showLegendKey val="0"/>
-              <c:showVal val="0"/>
-              <c:showCatName val="0"/>
-              <c:showSerName val="0"/>
-              <c:showPercent val="0"/>
-              <c:showBubbleSize val="0"/>
-            </c:dLbl>
-            <c:numFmt formatCode="General" sourceLinked="0"/>
-            <c:txPr>
-              <a:bodyPr/>
-              <a:lstStyle/>
-              <a:p>
-                <a:pPr>
-                  <a:defRPr sz="1800" b="0" i="0" u="none" strike="noStrike">
-                    <a:solidFill>
-                      <a:srgbClr val="000000"/>
-                    </a:solidFill>
-                    <a:latin typeface="Arial"/>
-                  </a:defRPr>
-                </a:pPr>
-              </a:p>
-            </c:txPr>
-            <c:showLegendKey val="0"/>
-            <c:showVal val="0"/>
-            <c:showCatName val="1"/>
-            <c:showSerName val="0"/>
-            <c:showPercent val="1"/>
-            <c:showBubbleSize val="0"/>
-            <c:showLeaderLines val="0"/>
-          </c:dLbls>
           <c:cat>
             <c:strRef>
               <c:f>Sheet1!$A$2:$A$3</c:f>
@@ -281,6 +224,7 @@
             <c:numRef>
               <c:f>Sheet1!$B$2:$B$3</c:f>
               <c:numCache>
+                <c:formatCode>General</c:formatCode>
                 <c:ptCount val="2"/>
                 <c:pt idx="0">
                   <c:v>635413</c:v>
@@ -291,7 +235,21 @@
               </c:numCache>
             </c:numRef>
           </c:val>
+          <c:extLst>
+            <c:ext xmlns:c16="http://schemas.microsoft.com/office/drawing/2014/chart" uri="{C3380CC4-5D6E-409C-BE32-E72D297353CC}">
+              <c16:uniqueId val="{00000004-9FC8-4944-AA4A-9EC6112069A9}"/>
+            </c:ext>
+          </c:extLst>
         </c:ser>
+        <c:dLbls>
+          <c:showLegendKey val="0"/>
+          <c:showVal val="0"/>
+          <c:showCatName val="0"/>
+          <c:showSerName val="0"/>
+          <c:showPercent val="0"/>
+          <c:showBubbleSize val="0"/>
+          <c:showLeaderLines val="0"/>
+        </c:dLbls>
         <c:firstSliceAng val="0"/>
         <c:holeSize val="62"/>
       </c:doughnutChart>
@@ -323,6 +281,7 @@
     </c:legend>
     <c:plotVisOnly val="1"/>
     <c:dispBlanksAs val="span"/>
+    <c:showDLblsOverMax val="1"/>
   </c:chart>
   <c:spPr>
     <a:noFill/>
@@ -338,9 +297,11 @@
 </file>
 
 <file path=ppt/charts/chart2.xml><?xml version="1.0" encoding="utf-8"?>
-<c:chartSpace xmlns:c="http://schemas.openxmlformats.org/drawingml/2006/chart" xmlns:a="http://schemas.openxmlformats.org/drawingml/2006/main" xmlns:r="http://schemas.openxmlformats.org/officeDocument/2006/relationships">
+<c:chartSpace xmlns:c="http://schemas.openxmlformats.org/drawingml/2006/chart" xmlns:a="http://schemas.openxmlformats.org/drawingml/2006/main" xmlns:r="http://schemas.openxmlformats.org/officeDocument/2006/relationships" xmlns:c16r2="http://schemas.microsoft.com/office/drawing/2015/06/chart">
   <c:date1904 val="0"/>
+  <c:lang val="en-US"/>
   <c:roundedCorners val="1"/>
+  <c:style val="2"/>
   <c:chart>
     <c:autoTitleDeleted val="1"/>
     <c:plotArea>
@@ -372,18 +333,26 @@
           <c:invertIfNegative val="0"/>
           <c:dLbls>
             <c:numFmt formatCode="0.00&quot;%&quot;" sourceLinked="0"/>
+            <c:spPr>
+              <a:noFill/>
+              <a:ln>
+                <a:noFill/>
+              </a:ln>
+              <a:effectLst/>
+            </c:spPr>
             <c:txPr>
               <a:bodyPr/>
               <a:lstStyle/>
               <a:p>
                 <a:pPr>
-                  <a:defRPr b="0" i="0" strike="noStrike" sz="1100" u="none">
+                  <a:defRPr sz="1100" b="0" i="0" u="none" strike="noStrike">
                     <a:solidFill>
                       <a:srgbClr val="1A1A1A"/>
                     </a:solidFill>
                     <a:latin typeface="Arial"/>
                   </a:defRPr>
                 </a:pPr>
+                <a:endParaRPr lang="en-US"/>
               </a:p>
             </c:txPr>
             <c:showLegendKey val="0"/>
@@ -393,31 +362,34 @@
             <c:showPercent val="0"/>
             <c:showBubbleSize val="0"/>
             <c:showLeaderLines val="0"/>
+            <c:extLst>
+              <c:ext xmlns:c15="http://schemas.microsoft.com/office/drawing/2012/chart" uri="{CE6537A1-D6FC-4f65-9D91-7224C49458BB}">
+                <c15:showLeaderLines val="0"/>
+              </c:ext>
+            </c:extLst>
           </c:dLbls>
           <c:cat>
-            <c:multiLvlStrRef>
+            <c:strRef>
               <c:f>Sheet1!$A$2:$A$6</c:f>
-              <c:multiLvlStrCache>
+              <c:strCache>
                 <c:ptCount val="5"/>
-                <c:lvl>
-                  <c:pt idx="0">
-                    <c:v>TRANSFER</c:v>
-                  </c:pt>
-                  <c:pt idx="1">
-                    <c:v>CASH_OUT</c:v>
-                  </c:pt>
-                  <c:pt idx="2">
-                    <c:v>PAYMENT</c:v>
-                  </c:pt>
-                  <c:pt idx="3">
-                    <c:v>CASH_IN</c:v>
-                  </c:pt>
-                  <c:pt idx="4">
-                    <c:v>DEBIT</c:v>
-                  </c:pt>
-                </c:lvl>
-              </c:multiLvlStrCache>
-            </c:multiLvlStrRef>
+                <c:pt idx="0">
+                  <c:v>TRANSFER</c:v>
+                </c:pt>
+                <c:pt idx="1">
+                  <c:v>CASH_OUT</c:v>
+                </c:pt>
+                <c:pt idx="2">
+                  <c:v>PAYMENT</c:v>
+                </c:pt>
+                <c:pt idx="3">
+                  <c:v>CASH_IN</c:v>
+                </c:pt>
+                <c:pt idx="4">
+                  <c:v>DEBIT</c:v>
+                </c:pt>
+              </c:strCache>
+            </c:strRef>
           </c:cat>
           <c:val>
             <c:numRef>
@@ -426,7 +398,7 @@
                 <c:formatCode>General</c:formatCode>
                 <c:ptCount val="5"/>
                 <c:pt idx="0">
-                  <c:v>0.811</c:v>
+                  <c:v>0.81100000000000005</c:v>
                 </c:pt>
                 <c:pt idx="1">
                   <c:v>0.186</c:v>
@@ -443,36 +415,23 @@
               </c:numCache>
             </c:numRef>
           </c:val>
+          <c:extLst>
+            <c:ext xmlns:c16="http://schemas.microsoft.com/office/drawing/2014/chart" uri="{C3380CC4-5D6E-409C-BE32-E72D297353CC}">
+              <c16:uniqueId val="{00000000-37CF-49D5-B8A8-2CD3E0026BCB}"/>
+            </c:ext>
+          </c:extLst>
         </c:ser>
         <c:dLbls>
-          <c:numFmt formatCode="0.00&quot;%&quot;" sourceLinked="0"/>
-          <c:txPr>
-            <a:bodyPr/>
-            <a:lstStyle/>
-            <a:p>
-              <a:pPr>
-                <a:defRPr b="0" i="0" strike="noStrike" sz="1100" u="none">
-                  <a:solidFill>
-                    <a:srgbClr val="1A1A1A"/>
-                  </a:solidFill>
-                  <a:latin typeface="Arial"/>
-                </a:defRPr>
-              </a:pPr>
-            </a:p>
-          </c:txPr>
           <c:showLegendKey val="0"/>
           <c:showVal val="1"/>
           <c:showCatName val="0"/>
           <c:showSerName val="0"/>
           <c:showPercent val="0"/>
           <c:showBubbleSize val="0"/>
-          <c:showLeaderLines val="0"/>
         </c:dLbls>
         <c:gapWidth val="60"/>
-        <c:overlap val="0"/>
         <c:axId val="2094734554"/>
         <c:axId val="2094734552"/>
-        <c:axId val="2094734556"/>
       </c:barChart>
       <c:catAx>
         <c:axId val="2094734554"/>
@@ -513,6 +472,7 @@
         <c:crosses val="autoZero"/>
         <c:auto val="1"/>
         <c:lblAlgn val="ctr"/>
+        <c:lblOffset val="100"/>
         <c:noMultiLvlLbl val="1"/>
       </c:catAx>
       <c:valAx>
@@ -576,6 +536,7 @@
     </c:plotArea>
     <c:plotVisOnly val="1"/>
     <c:dispBlanksAs val="span"/>
+    <c:showDLblsOverMax val="1"/>
   </c:chart>
   <c:spPr>
     <a:noFill/>
@@ -591,354 +552,11 @@
 </file>
 
 <file path=ppt/charts/chart3.xml><?xml version="1.0" encoding="utf-8"?>
-<c:chartSpace xmlns:c="http://schemas.openxmlformats.org/drawingml/2006/chart" xmlns:a="http://schemas.openxmlformats.org/drawingml/2006/main" xmlns:r="http://schemas.openxmlformats.org/officeDocument/2006/relationships">
+<c:chartSpace xmlns:c="http://schemas.openxmlformats.org/drawingml/2006/chart" xmlns:a="http://schemas.openxmlformats.org/drawingml/2006/main" xmlns:r="http://schemas.openxmlformats.org/officeDocument/2006/relationships" xmlns:c16r2="http://schemas.microsoft.com/office/drawing/2015/06/chart">
   <c:date1904 val="0"/>
+  <c:lang val="en-US"/>
   <c:roundedCorners val="1"/>
-  <c:chart>
-    <c:autoTitleDeleted val="1"/>
-    <c:plotArea>
-      <c:layout/>
-      <c:lineChart>
-        <c:varyColors val="0"/>
-        <c:ser>
-          <c:idx val="0"/>
-          <c:order val="0"/>
-          <c:tx>
-            <c:strRef>
-              <c:f>Sheet1!$B$1</c:f>
-              <c:strCache>
-                <c:ptCount val="1"/>
-                <c:pt idx="0">
-                  <c:v>Fraud rate %</c:v>
-                </c:pt>
-              </c:strCache>
-            </c:strRef>
-          </c:tx>
-          <c:spPr>
-            <a:solidFill>
-              <a:srgbClr val="D0021B"/>
-            </a:solidFill>
-            <a:ln w="38100" cap="flat">
-              <a:solidFill>
-                <a:srgbClr val="D0021B"/>
-              </a:solidFill>
-              <a:prstDash val="solid"/>
-              <a:round/>
-            </a:ln>
-            <a:effectLst/>
-          </c:spPr>
-          <c:invertIfNegative val="0"/>
-          <c:dLbls>
-            <c:numFmt formatCode="#,##0" sourceLinked="0"/>
-            <c:txPr>
-              <a:bodyPr/>
-              <a:lstStyle/>
-              <a:p>
-                <a:pPr>
-                  <a:defRPr b="0" i="0" strike="noStrike" sz="1200" u="none">
-                    <a:solidFill>
-                      <a:srgbClr val="000000"/>
-                    </a:solidFill>
-                    <a:latin typeface="Arial"/>
-                  </a:defRPr>
-                </a:pPr>
-              </a:p>
-            </c:txPr>
-            <c:showLegendKey val="0"/>
-            <c:showVal val="0"/>
-            <c:showCatName val="0"/>
-            <c:showSerName val="0"/>
-            <c:showPercent val="0"/>
-            <c:showBubbleSize val="0"/>
-            <c:showLeaderLines val="0"/>
-          </c:dLbls>
-          <c:marker>
-            <c:symbol val="circle"/>
-            <c:size val="6"/>
-            <c:spPr>
-              <a:solidFill>
-                <a:srgbClr val="D0021B"/>
-              </a:solidFill>
-              <a:ln w="9525" cap="flat">
-                <a:solidFill>
-                  <a:srgbClr val="D0021B"/>
-                </a:solidFill>
-                <a:prstDash val="solid"/>
-                <a:round/>
-              </a:ln>
-              <a:effectLst/>
-            </c:spPr>
-          </c:marker>
-          <c:cat>
-            <c:multiLvlStrRef>
-              <c:f>Sheet1!$A$2:$A$13</c:f>
-              <c:multiLvlStrCache>
-                <c:ptCount val="12"/>
-                <c:lvl>
-                  <c:pt idx="0">
-                    <c:v>0</c:v>
-                  </c:pt>
-                  <c:pt idx="1">
-                    <c:v>2</c:v>
-                  </c:pt>
-                  <c:pt idx="2">
-                    <c:v>4</c:v>
-                  </c:pt>
-                  <c:pt idx="3">
-                    <c:v>6</c:v>
-                  </c:pt>
-                  <c:pt idx="4">
-                    <c:v>8</c:v>
-                  </c:pt>
-                  <c:pt idx="5">
-                    <c:v>10</c:v>
-                  </c:pt>
-                  <c:pt idx="6">
-                    <c:v>12</c:v>
-                  </c:pt>
-                  <c:pt idx="7">
-                    <c:v>14</c:v>
-                  </c:pt>
-                  <c:pt idx="8">
-                    <c:v>16</c:v>
-                  </c:pt>
-                  <c:pt idx="9">
-                    <c:v>18</c:v>
-                  </c:pt>
-                  <c:pt idx="10">
-                    <c:v>20</c:v>
-                  </c:pt>
-                  <c:pt idx="11">
-                    <c:v>22</c:v>
-                  </c:pt>
-                </c:lvl>
-              </c:multiLvlStrCache>
-            </c:multiLvlStrRef>
-          </c:cat>
-          <c:val>
-            <c:numRef>
-              <c:f>Sheet1!$B$2:$B$13</c:f>
-              <c:numCache>
-                <c:formatCode>General</c:formatCode>
-                <c:ptCount val="12"/>
-                <c:pt idx="0">
-                  <c:v>0.39</c:v>
-                </c:pt>
-                <c:pt idx="1">
-                  <c:v>4.24</c:v>
-                </c:pt>
-                <c:pt idx="2">
-                  <c:v>21.85</c:v>
-                </c:pt>
-                <c:pt idx="3">
-                  <c:v>11.24</c:v>
-                </c:pt>
-                <c:pt idx="4">
-                  <c:v>1.57</c:v>
-                </c:pt>
-                <c:pt idx="5">
-                  <c:v>0.11</c:v>
-                </c:pt>
-                <c:pt idx="6">
-                  <c:v>0.08</c:v>
-                </c:pt>
-                <c:pt idx="7">
-                  <c:v>0.06</c:v>
-                </c:pt>
-                <c:pt idx="8">
-                  <c:v>0.08</c:v>
-                </c:pt>
-                <c:pt idx="9">
-                  <c:v>0.06</c:v>
-                </c:pt>
-                <c:pt idx="10">
-                  <c:v>0.06</c:v>
-                </c:pt>
-                <c:pt idx="11">
-                  <c:v>0.22</c:v>
-                </c:pt>
-              </c:numCache>
-            </c:numRef>
-          </c:val>
-          <c:smooth val="1"/>
-        </c:ser>
-        <c:dLbls>
-          <c:numFmt formatCode="#,##0" sourceLinked="0"/>
-          <c:txPr>
-            <a:bodyPr/>
-            <a:lstStyle/>
-            <a:p>
-              <a:pPr>
-                <a:defRPr b="0" i="0" strike="noStrike" sz="1200" u="none">
-                  <a:solidFill>
-                    <a:srgbClr val="000000"/>
-                  </a:solidFill>
-                  <a:latin typeface="Arial"/>
-                </a:defRPr>
-              </a:pPr>
-            </a:p>
-          </c:txPr>
-          <c:showLegendKey val="0"/>
-          <c:showVal val="0"/>
-          <c:showCatName val="0"/>
-          <c:showSerName val="0"/>
-          <c:showPercent val="0"/>
-          <c:showBubbleSize val="0"/>
-          <c:showLeaderLines val="0"/>
-        </c:dLbls>
-        <c:marker val="1"/>
-        <c:axId val="2094734554"/>
-        <c:axId val="2094734552"/>
-        <c:axId val="2094734556"/>
-      </c:lineChart>
-      <c:catAx>
-        <c:axId val="2094734554"/>
-        <c:scaling>
-          <c:orientation val="minMax"/>
-        </c:scaling>
-        <c:delete val="0"/>
-        <c:axPos val="b"/>
-        <c:title>
-          <c:tx>
-            <c:rich>
-              <a:bodyPr/>
-              <a:lstStyle/>
-              <a:p>
-                <a:pPr>
-                  <a:defRPr sz="1100" b="0" i="0" u="none" strike="noStrike">
-                    <a:solidFill>
-                      <a:srgbClr val="4A4F57"/>
-                    </a:solidFill>
-                    <a:latin typeface="Arial"/>
-                  </a:defRPr>
-                </a:pPr>
-                <a:r>
-                  <a:rPr sz="1100" b="0" i="0" u="none" strike="noStrike">
-                    <a:solidFill>
-                      <a:srgbClr val="4A4F57"/>
-                    </a:solidFill>
-                    <a:latin typeface="Arial"/>
-                  </a:rPr>
-                  <a:t>Position in the 24 step cycle</a:t>
-                </a:r>
-              </a:p>
-            </c:rich>
-          </c:tx>
-          <c:layout/>
-          <c:overlay val="0"/>
-        </c:title>
-        <c:numFmt formatCode="General" sourceLinked="1"/>
-        <c:majorTickMark val="out"/>
-        <c:minorTickMark val="none"/>
-        <c:tickLblPos val="low"/>
-        <c:spPr>
-          <a:ln w="12700" cap="flat">
-            <a:solidFill>
-              <a:srgbClr val="888888"/>
-            </a:solidFill>
-            <a:prstDash val="solid"/>
-            <a:round/>
-          </a:ln>
-        </c:spPr>
-        <c:txPr>
-          <a:bodyPr/>
-          <a:lstStyle/>
-          <a:p>
-            <a:pPr>
-              <a:defRPr sz="1000" b="0" i="0" u="none" strike="noStrike">
-                <a:solidFill>
-                  <a:srgbClr val="4A4F57"/>
-                </a:solidFill>
-                <a:latin typeface="Arial"/>
-              </a:defRPr>
-            </a:pPr>
-            <a:endParaRPr lang="en-US"/>
-          </a:p>
-        </c:txPr>
-        <c:crossAx val="2094734552"/>
-        <c:crosses val="autoZero"/>
-        <c:auto val="1"/>
-        <c:lblAlgn val="ctr"/>
-        <c:noMultiLvlLbl val="1"/>
-      </c:catAx>
-      <c:valAx>
-        <c:axId val="2094734552"/>
-        <c:scaling>
-          <c:orientation val="minMax"/>
-        </c:scaling>
-        <c:delete val="0"/>
-        <c:axPos val="l"/>
-        <c:majorGridlines>
-          <c:spPr>
-            <a:ln w="12700" cap="flat">
-              <a:solidFill>
-                <a:srgbClr val="D5DEEF"/>
-              </a:solidFill>
-              <a:prstDash val="solid"/>
-              <a:round/>
-            </a:ln>
-          </c:spPr>
-        </c:majorGridlines>
-        <c:numFmt formatCode="General" sourceLinked="0"/>
-        <c:majorTickMark val="out"/>
-        <c:minorTickMark val="none"/>
-        <c:tickLblPos val="nextTo"/>
-        <c:spPr>
-          <a:ln w="12700" cap="flat">
-            <a:solidFill>
-              <a:srgbClr val="888888"/>
-            </a:solidFill>
-            <a:prstDash val="solid"/>
-            <a:round/>
-          </a:ln>
-        </c:spPr>
-        <c:txPr>
-          <a:bodyPr/>
-          <a:lstStyle/>
-          <a:p>
-            <a:pPr>
-              <a:defRPr sz="1000" b="0" i="0" u="none" strike="noStrike">
-                <a:solidFill>
-                  <a:srgbClr val="4A4F57"/>
-                </a:solidFill>
-                <a:latin typeface="Arial"/>
-              </a:defRPr>
-            </a:pPr>
-            <a:endParaRPr lang="en-US"/>
-          </a:p>
-        </c:txPr>
-        <c:crossAx val="2094734554"/>
-        <c:crosses val="autoZero"/>
-        <c:crossBetween val="between"/>
-      </c:valAx>
-      <c:spPr>
-        <a:noFill/>
-        <a:ln>
-          <a:noFill/>
-        </a:ln>
-        <a:effectLst/>
-      </c:spPr>
-    </c:plotArea>
-    <c:plotVisOnly val="1"/>
-    <c:dispBlanksAs val="span"/>
-  </c:chart>
-  <c:spPr>
-    <a:noFill/>
-    <a:ln>
-      <a:noFill/>
-    </a:ln>
-    <a:effectLst/>
-  </c:spPr>
-  <c:externalData r:id="rId1">
-    <c:autoUpdate val="0"/>
-  </c:externalData>
-</c:chartSpace>
-</file>
-
-<file path=ppt/charts/chart4.xml><?xml version="1.0" encoding="utf-8"?>
-<c:chartSpace xmlns:c="http://schemas.openxmlformats.org/drawingml/2006/chart" xmlns:a="http://schemas.openxmlformats.org/drawingml/2006/main" xmlns:r="http://schemas.openxmlformats.org/officeDocument/2006/relationships">
-  <c:date1904 val="0"/>
-  <c:roundedCorners val="1"/>
+  <c:style val="2"/>
   <c:chart>
     <c:autoTitleDeleted val="1"/>
     <c:plotArea>
@@ -968,40 +586,15 @@
             <a:effectLst/>
           </c:spPr>
           <c:invertIfNegative val="0"/>
-          <c:dLbls>
-            <c:numFmt formatCode="0.000" sourceLinked="0"/>
-            <c:txPr>
-              <a:bodyPr/>
-              <a:lstStyle/>
-              <a:p>
-                <a:pPr>
-                  <a:defRPr b="0" i="0" strike="noStrike" sz="1200" u="none">
-                    <a:solidFill>
-                      <a:srgbClr val="1A1A1A"/>
-                    </a:solidFill>
-                    <a:latin typeface="Arial"/>
-                  </a:defRPr>
-                </a:pPr>
-              </a:p>
-            </c:txPr>
-            <c:showLegendKey val="0"/>
-            <c:showVal val="1"/>
-            <c:showCatName val="0"/>
-            <c:showSerName val="0"/>
-            <c:showPercent val="0"/>
-            <c:showBubbleSize val="0"/>
-            <c:showLeaderLines val="0"/>
-          </c:dLbls>
           <c:dPt>
             <c:idx val="0"/>
             <c:invertIfNegative val="0"/>
             <c:bubble3D val="0"/>
-            <c:spPr>
-              <a:solidFill>
-                <a:srgbClr val="AAAAAA"/>
-              </a:solidFill>
-              <a:effectLst/>
-            </c:spPr>
+            <c:extLst>
+              <c:ext xmlns:c16="http://schemas.microsoft.com/office/drawing/2014/chart" uri="{C3380CC4-5D6E-409C-BE32-E72D297353CC}">
+                <c16:uniqueId val="{00000001-D444-4804-B729-101F849B9F8F}"/>
+              </c:ext>
+            </c:extLst>
           </c:dPt>
           <c:dPt>
             <c:idx val="1"/>
@@ -1013,6 +606,11 @@
               </a:solidFill>
               <a:effectLst/>
             </c:spPr>
+            <c:extLst>
+              <c:ext xmlns:c16="http://schemas.microsoft.com/office/drawing/2014/chart" uri="{C3380CC4-5D6E-409C-BE32-E72D297353CC}">
+                <c16:uniqueId val="{00000003-D444-4804-B729-101F849B9F8F}"/>
+              </c:ext>
+            </c:extLst>
           </c:dPt>
           <c:dPt>
             <c:idx val="2"/>
@@ -1024,25 +622,65 @@
               </a:solidFill>
               <a:effectLst/>
             </c:spPr>
+            <c:extLst>
+              <c:ext xmlns:c16="http://schemas.microsoft.com/office/drawing/2014/chart" uri="{C3380CC4-5D6E-409C-BE32-E72D297353CC}">
+                <c16:uniqueId val="{00000005-D444-4804-B729-101F849B9F8F}"/>
+              </c:ext>
+            </c:extLst>
           </c:dPt>
+          <c:dLbls>
+            <c:numFmt formatCode="0.000" sourceLinked="0"/>
+            <c:spPr>
+              <a:noFill/>
+              <a:ln>
+                <a:noFill/>
+              </a:ln>
+              <a:effectLst/>
+            </c:spPr>
+            <c:txPr>
+              <a:bodyPr/>
+              <a:lstStyle/>
+              <a:p>
+                <a:pPr>
+                  <a:defRPr sz="1200" b="0" i="0" u="none" strike="noStrike">
+                    <a:solidFill>
+                      <a:srgbClr val="1A1A1A"/>
+                    </a:solidFill>
+                    <a:latin typeface="Arial"/>
+                  </a:defRPr>
+                </a:pPr>
+                <a:endParaRPr lang="en-US"/>
+              </a:p>
+            </c:txPr>
+            <c:showLegendKey val="0"/>
+            <c:showVal val="1"/>
+            <c:showCatName val="0"/>
+            <c:showSerName val="0"/>
+            <c:showPercent val="0"/>
+            <c:showBubbleSize val="0"/>
+            <c:showLeaderLines val="0"/>
+            <c:extLst>
+              <c:ext xmlns:c15="http://schemas.microsoft.com/office/drawing/2012/chart" uri="{CE6537A1-D6FC-4f65-9D91-7224C49458BB}">
+                <c15:showLeaderLines val="0"/>
+              </c:ext>
+            </c:extLst>
+          </c:dLbls>
           <c:cat>
-            <c:multiLvlStrRef>
+            <c:strRef>
               <c:f>Sheet1!$A$2:$A$4</c:f>
-              <c:multiLvlStrCache>
+              <c:strCache>
                 <c:ptCount val="3"/>
-                <c:lvl>
-                  <c:pt idx="0">
-                    <c:v>Basic features</c:v>
-                  </c:pt>
-                  <c:pt idx="1">
-                    <c:v>With balances (chosen)</c:v>
-                  </c:pt>
-                  <c:pt idx="2">
-                    <c:v>With balance errors (rejected)</c:v>
-                  </c:pt>
-                </c:lvl>
-              </c:multiLvlStrCache>
-            </c:multiLvlStrRef>
+                <c:pt idx="0">
+                  <c:v>Basic features</c:v>
+                </c:pt>
+                <c:pt idx="1">
+                  <c:v>With balances (chosen)</c:v>
+                </c:pt>
+                <c:pt idx="2">
+                  <c:v>With balance errors (rejected)</c:v>
+                </c:pt>
+              </c:strCache>
+            </c:strRef>
           </c:cat>
           <c:val>
             <c:numRef>
@@ -1051,47 +689,34 @@
                 <c:formatCode>General</c:formatCode>
                 <c:ptCount val="3"/>
                 <c:pt idx="0">
-                  <c:v>0.278</c:v>
+                  <c:v>0.27800000000000002</c:v>
                 </c:pt>
                 <c:pt idx="1">
-                  <c:v>0.832</c:v>
+                  <c:v>0.83199999999999996</c:v>
                 </c:pt>
                 <c:pt idx="2">
-                  <c:v>0.989</c:v>
+                  <c:v>0.98899999999999999</c:v>
                 </c:pt>
               </c:numCache>
             </c:numRef>
           </c:val>
+          <c:extLst>
+            <c:ext xmlns:c16="http://schemas.microsoft.com/office/drawing/2014/chart" uri="{C3380CC4-5D6E-409C-BE32-E72D297353CC}">
+              <c16:uniqueId val="{00000006-D444-4804-B729-101F849B9F8F}"/>
+            </c:ext>
+          </c:extLst>
         </c:ser>
         <c:dLbls>
-          <c:numFmt formatCode="0.000" sourceLinked="0"/>
-          <c:txPr>
-            <a:bodyPr/>
-            <a:lstStyle/>
-            <a:p>
-              <a:pPr>
-                <a:defRPr b="0" i="0" strike="noStrike" sz="1200" u="none">
-                  <a:solidFill>
-                    <a:srgbClr val="1A1A1A"/>
-                  </a:solidFill>
-                  <a:latin typeface="Arial"/>
-                </a:defRPr>
-              </a:pPr>
-            </a:p>
-          </c:txPr>
           <c:showLegendKey val="0"/>
           <c:showVal val="1"/>
           <c:showCatName val="0"/>
           <c:showSerName val="0"/>
           <c:showPercent val="0"/>
           <c:showBubbleSize val="0"/>
-          <c:showLeaderLines val="0"/>
         </c:dLbls>
         <c:gapWidth val="55"/>
-        <c:overlap val="0"/>
         <c:axId val="2094734554"/>
         <c:axId val="2094734552"/>
-        <c:axId val="2094734556"/>
       </c:barChart>
       <c:catAx>
         <c:axId val="2094734554"/>
@@ -1132,13 +757,14 @@
         <c:crosses val="autoZero"/>
         <c:auto val="1"/>
         <c:lblAlgn val="ctr"/>
+        <c:lblOffset val="100"/>
         <c:noMultiLvlLbl val="1"/>
       </c:catAx>
       <c:valAx>
         <c:axId val="2094734552"/>
         <c:scaling>
           <c:orientation val="minMax"/>
-          <c:max val="1.1"/>
+          <c:max val="1.1000000000000001"/>
         </c:scaling>
         <c:delete val="0"/>
         <c:axPos val="b"/>
@@ -1195,6 +821,7 @@
     </c:plotArea>
     <c:plotVisOnly val="1"/>
     <c:dispBlanksAs val="span"/>
+    <c:showDLblsOverMax val="1"/>
   </c:chart>
   <c:spPr>
     <a:noFill/>
@@ -1209,10 +836,12 @@
 </c:chartSpace>
 </file>
 
-<file path=ppt/charts/chart5.xml><?xml version="1.0" encoding="utf-8"?>
-<c:chartSpace xmlns:c="http://schemas.openxmlformats.org/drawingml/2006/chart" xmlns:a="http://schemas.openxmlformats.org/drawingml/2006/main" xmlns:r="http://schemas.openxmlformats.org/officeDocument/2006/relationships">
+<file path=ppt/charts/chart4.xml><?xml version="1.0" encoding="utf-8"?>
+<c:chartSpace xmlns:c="http://schemas.openxmlformats.org/drawingml/2006/chart" xmlns:a="http://schemas.openxmlformats.org/drawingml/2006/main" xmlns:r="http://schemas.openxmlformats.org/officeDocument/2006/relationships" xmlns:c16r2="http://schemas.microsoft.com/office/drawing/2015/06/chart">
   <c:date1904 val="0"/>
+  <c:lang val="en-US"/>
   <c:roundedCorners val="1"/>
+  <c:style val="2"/>
   <c:chart>
     <c:autoTitleDeleted val="1"/>
     <c:plotArea>
@@ -1242,40 +871,15 @@
             <a:effectLst/>
           </c:spPr>
           <c:invertIfNegative val="0"/>
-          <c:dLbls>
-            <c:numFmt formatCode="&quot;R&quot;#,##0" sourceLinked="0"/>
-            <c:txPr>
-              <a:bodyPr/>
-              <a:lstStyle/>
-              <a:p>
-                <a:pPr>
-                  <a:defRPr b="0" i="0" strike="noStrike" sz="1200" u="none">
-                    <a:solidFill>
-                      <a:srgbClr val="1A1A1A"/>
-                    </a:solidFill>
-                    <a:latin typeface="Arial"/>
-                  </a:defRPr>
-                </a:pPr>
-              </a:p>
-            </c:txPr>
-            <c:showLegendKey val="0"/>
-            <c:showVal val="1"/>
-            <c:showCatName val="0"/>
-            <c:showSerName val="0"/>
-            <c:showPercent val="0"/>
-            <c:showBubbleSize val="0"/>
-            <c:showLeaderLines val="0"/>
-          </c:dLbls>
           <c:dPt>
             <c:idx val="0"/>
             <c:invertIfNegative val="0"/>
             <c:bubble3D val="0"/>
-            <c:spPr>
-              <a:solidFill>
-                <a:srgbClr val="D0021B"/>
-              </a:solidFill>
-              <a:effectLst/>
-            </c:spPr>
+            <c:extLst>
+              <c:ext xmlns:c16="http://schemas.microsoft.com/office/drawing/2014/chart" uri="{C3380CC4-5D6E-409C-BE32-E72D297353CC}">
+                <c16:uniqueId val="{00000001-F4E7-46C5-A13A-B938D9F877E5}"/>
+              </c:ext>
+            </c:extLst>
           </c:dPt>
           <c:dPt>
             <c:idx val="1"/>
@@ -1287,6 +891,11 @@
               </a:solidFill>
               <a:effectLst/>
             </c:spPr>
+            <c:extLst>
+              <c:ext xmlns:c16="http://schemas.microsoft.com/office/drawing/2014/chart" uri="{C3380CC4-5D6E-409C-BE32-E72D297353CC}">
+                <c16:uniqueId val="{00000003-F4E7-46C5-A13A-B938D9F877E5}"/>
+              </c:ext>
+            </c:extLst>
           </c:dPt>
           <c:dPt>
             <c:idx val="2"/>
@@ -1298,25 +907,65 @@
               </a:solidFill>
               <a:effectLst/>
             </c:spPr>
+            <c:extLst>
+              <c:ext xmlns:c16="http://schemas.microsoft.com/office/drawing/2014/chart" uri="{C3380CC4-5D6E-409C-BE32-E72D297353CC}">
+                <c16:uniqueId val="{00000005-F4E7-46C5-A13A-B938D9F877E5}"/>
+              </c:ext>
+            </c:extLst>
           </c:dPt>
+          <c:dLbls>
+            <c:numFmt formatCode="&quot;R&quot;#,##0" sourceLinked="0"/>
+            <c:spPr>
+              <a:noFill/>
+              <a:ln>
+                <a:noFill/>
+              </a:ln>
+              <a:effectLst/>
+            </c:spPr>
+            <c:txPr>
+              <a:bodyPr/>
+              <a:lstStyle/>
+              <a:p>
+                <a:pPr>
+                  <a:defRPr sz="1200" b="0" i="0" u="none" strike="noStrike">
+                    <a:solidFill>
+                      <a:srgbClr val="1A1A1A"/>
+                    </a:solidFill>
+                    <a:latin typeface="Arial"/>
+                  </a:defRPr>
+                </a:pPr>
+                <a:endParaRPr lang="en-US"/>
+              </a:p>
+            </c:txPr>
+            <c:showLegendKey val="0"/>
+            <c:showVal val="1"/>
+            <c:showCatName val="0"/>
+            <c:showSerName val="0"/>
+            <c:showPercent val="0"/>
+            <c:showBubbleSize val="0"/>
+            <c:showLeaderLines val="0"/>
+            <c:extLst>
+              <c:ext xmlns:c15="http://schemas.microsoft.com/office/drawing/2012/chart" uri="{CE6537A1-D6FC-4f65-9D91-7224C49458BB}">
+                <c15:showLeaderLines val="0"/>
+              </c:ext>
+            </c:extLst>
+          </c:dLbls>
           <c:cat>
-            <c:multiLvlStrRef>
+            <c:strRef>
               <c:f>Sheet1!$A$2:$A$4</c:f>
-              <c:multiLvlStrCache>
+              <c:strCache>
                 <c:ptCount val="3"/>
-                <c:lvl>
-                  <c:pt idx="0">
-                    <c:v>No model at all</c:v>
-                  </c:pt>
-                  <c:pt idx="1">
-                    <c:v>Best F1 balance</c:v>
-                  </c:pt>
-                  <c:pt idx="2">
-                    <c:v>Lowest business cost</c:v>
-                  </c:pt>
-                </c:lvl>
-              </c:multiLvlStrCache>
-            </c:multiLvlStrRef>
+                <c:pt idx="0">
+                  <c:v>No model at all</c:v>
+                </c:pt>
+                <c:pt idx="1">
+                  <c:v>Best F1 balance</c:v>
+                </c:pt>
+                <c:pt idx="2">
+                  <c:v>Lowest business cost</c:v>
+                </c:pt>
+              </c:strCache>
+            </c:strRef>
           </c:cat>
           <c:val>
             <c:numRef>
@@ -1336,36 +985,23 @@
               </c:numCache>
             </c:numRef>
           </c:val>
+          <c:extLst>
+            <c:ext xmlns:c16="http://schemas.microsoft.com/office/drawing/2014/chart" uri="{C3380CC4-5D6E-409C-BE32-E72D297353CC}">
+              <c16:uniqueId val="{00000006-F4E7-46C5-A13A-B938D9F877E5}"/>
+            </c:ext>
+          </c:extLst>
         </c:ser>
         <c:dLbls>
-          <c:numFmt formatCode="&quot;R&quot;#,##0" sourceLinked="0"/>
-          <c:txPr>
-            <a:bodyPr/>
-            <a:lstStyle/>
-            <a:p>
-              <a:pPr>
-                <a:defRPr b="0" i="0" strike="noStrike" sz="1200" u="none">
-                  <a:solidFill>
-                    <a:srgbClr val="1A1A1A"/>
-                  </a:solidFill>
-                  <a:latin typeface="Arial"/>
-                </a:defRPr>
-              </a:pPr>
-            </a:p>
-          </c:txPr>
           <c:showLegendKey val="0"/>
           <c:showVal val="1"/>
           <c:showCatName val="0"/>
           <c:showSerName val="0"/>
           <c:showPercent val="0"/>
           <c:showBubbleSize val="0"/>
-          <c:showLeaderLines val="0"/>
         </c:dLbls>
         <c:gapWidth val="55"/>
-        <c:overlap val="0"/>
         <c:axId val="2094734554"/>
         <c:axId val="2094734552"/>
-        <c:axId val="2094734556"/>
       </c:barChart>
       <c:catAx>
         <c:axId val="2094734554"/>
@@ -1406,6 +1042,7 @@
         <c:crosses val="autoZero"/>
         <c:auto val="1"/>
         <c:lblAlgn val="ctr"/>
+        <c:lblOffset val="100"/>
         <c:noMultiLvlLbl val="1"/>
       </c:catAx>
       <c:valAx>
@@ -1468,6 +1105,7 @@
     </c:plotArea>
     <c:plotVisOnly val="1"/>
     <c:dispBlanksAs val="span"/>
+    <c:showDLblsOverMax val="1"/>
   </c:chart>
   <c:spPr>
     <a:noFill/>
@@ -1504,234 +1142,10 @@
           <a:chExt cx="0" cy="0"/>
         </a:xfrm>
       </p:grpSpPr>
-      <p:sp>
-        <p:nvSpPr>
-          <p:cNvPr id="2" name="Header Placeholder 1"/>
-          <p:cNvSpPr>
-            <a:spLocks noGrp="1"/>
-          </p:cNvSpPr>
-          <p:nvPr>
-            <p:ph type="hdr" sz="quarter"/>
-          </p:nvPr>
-        </p:nvSpPr>
-        <p:spPr>
-          <a:xfrm>
-            <a:off x="0" y="0"/>
-            <a:ext cx="2971800" cy="458788"/>
-          </a:xfrm>
-          <a:prstGeom prst="rect">
-            <a:avLst/>
-          </a:prstGeom>
-        </p:spPr>
-        <p:txBody>
-          <a:bodyPr vert="horz" lIns="91440" tIns="45720" rIns="91440" bIns="45720" rtlCol="0"/>
-          <a:lstStyle>
-            <a:lvl1pPr algn="l">
-              <a:defRPr sz="1200"/>
-            </a:lvl1pPr>
-          </a:lstStyle>
-          <a:p>
-            <a:endParaRPr lang="en-US"/>
-          </a:p>
-        </p:txBody>
-      </p:sp>
-      <p:sp>
-        <p:nvSpPr>
-          <p:cNvPr id="3" name="Date Placeholder 2"/>
-          <p:cNvSpPr>
-            <a:spLocks noGrp="1"/>
-          </p:cNvSpPr>
-          <p:nvPr>
-            <p:ph type="dt" idx="1"/>
-          </p:nvPr>
-        </p:nvSpPr>
-        <p:spPr>
-          <a:xfrm>
-            <a:off x="3884613" y="0"/>
-            <a:ext cx="2971800" cy="458788"/>
-          </a:xfrm>
-          <a:prstGeom prst="rect">
-            <a:avLst/>
-          </a:prstGeom>
-        </p:spPr>
-        <p:txBody>
-          <a:bodyPr vert="horz" lIns="91440" tIns="45720" rIns="91440" bIns="45720" rtlCol="0"/>
-          <a:lstStyle>
-            <a:lvl1pPr algn="r">
-              <a:defRPr sz="1200"/>
-            </a:lvl1pPr>
-          </a:lstStyle>
-          <a:p>
-            <a:fld id="{5282F153-3F37-0F45-9E97-73ACFA13230C}" type="datetimeFigureOut">
-              <a:rPr lang="en-US"/>
-              <a:t>7/23/19</a:t>
-            </a:fld>
-            <a:endParaRPr lang="en-US"/>
-          </a:p>
-        </p:txBody>
-      </p:sp>
-      <p:sp>
-        <p:nvSpPr>
-          <p:cNvPr id="4" name="Slide Image Placeholder 3"/>
-          <p:cNvSpPr>
-            <a:spLocks noGrp="1" noRot="1" noChangeAspect="1"/>
-          </p:cNvSpPr>
-          <p:nvPr>
-            <p:ph type="sldImg" idx="2"/>
-          </p:nvPr>
-        </p:nvSpPr>
-        <p:spPr>
-          <a:xfrm>
-            <a:off x="685800" y="1143000"/>
-            <a:ext cx="5486400" cy="3086100"/>
-          </a:xfrm>
-          <a:prstGeom prst="rect">
-            <a:avLst/>
-          </a:prstGeom>
-          <a:noFill/>
-          <a:ln w="12700">
-            <a:solidFill>
-              <a:prstClr val="black"/>
-            </a:solidFill>
-          </a:ln>
-        </p:spPr>
-        <p:txBody>
-          <a:bodyPr vert="horz" lIns="91440" tIns="45720" rIns="91440" bIns="45720" rtlCol="0" anchor="ctr"/>
-          <a:lstStyle/>
-          <a:p>
-            <a:endParaRPr lang="en-US"/>
-          </a:p>
-        </p:txBody>
-      </p:sp>
-      <p:sp>
-        <p:nvSpPr>
-          <p:cNvPr id="5" name="Notes Placeholder 4"/>
-          <p:cNvSpPr>
-            <a:spLocks noGrp="1"/>
-          </p:cNvSpPr>
-          <p:nvPr>
-            <p:ph type="body" sz="quarter" idx="3"/>
-          </p:nvPr>
-        </p:nvSpPr>
-        <p:spPr>
-          <a:xfrm>
-            <a:off x="685800" y="4400550"/>
-            <a:ext cx="5486400" cy="3600450"/>
-          </a:xfrm>
-          <a:prstGeom prst="rect">
-            <a:avLst/>
-          </a:prstGeom>
-        </p:spPr>
-        <p:txBody>
-          <a:bodyPr vert="horz" lIns="91440" tIns="45720" rIns="91440" bIns="45720" rtlCol="0"/>
-          <a:lstStyle/>
-          <a:p>
-            <a:pPr lvl="0"/>
-            <a:r>
-              <a:rPr lang="en-US"/>
-              <a:t>Click to edit Master text styles</a:t>
-            </a:r>
-          </a:p>
-          <a:p>
-            <a:pPr lvl="1"/>
-            <a:r>
-              <a:rPr lang="en-US"/>
-              <a:t>Second level</a:t>
-            </a:r>
-          </a:p>
-          <a:p>
-            <a:pPr lvl="2"/>
-            <a:r>
-              <a:rPr lang="en-US"/>
-              <a:t>Third level</a:t>
-            </a:r>
-          </a:p>
-          <a:p>
-            <a:pPr lvl="3"/>
-            <a:r>
-              <a:rPr lang="en-US"/>
-              <a:t>Fourth level</a:t>
-            </a:r>
-          </a:p>
-          <a:p>
-            <a:pPr lvl="4"/>
-            <a:r>
-              <a:rPr lang="en-US"/>
-              <a:t>Fifth level</a:t>
-            </a:r>
-          </a:p>
-        </p:txBody>
-      </p:sp>
-      <p:sp>
-        <p:nvSpPr>
-          <p:cNvPr id="6" name="Footer Placeholder 5"/>
-          <p:cNvSpPr>
-            <a:spLocks noGrp="1"/>
-          </p:cNvSpPr>
-          <p:nvPr>
-            <p:ph type="ftr" sz="quarter" idx="4"/>
-          </p:nvPr>
-        </p:nvSpPr>
-        <p:spPr>
-          <a:xfrm>
-            <a:off x="0" y="8685213"/>
-            <a:ext cx="2971800" cy="458787"/>
-          </a:xfrm>
-          <a:prstGeom prst="rect">
-            <a:avLst/>
-          </a:prstGeom>
-        </p:spPr>
-        <p:txBody>
-          <a:bodyPr vert="horz" lIns="91440" tIns="45720" rIns="91440" bIns="45720" rtlCol="0" anchor="b"/>
-          <a:lstStyle>
-            <a:lvl1pPr algn="l">
-              <a:defRPr sz="1200"/>
-            </a:lvl1pPr>
-          </a:lstStyle>
-          <a:p>
-            <a:endParaRPr lang="en-US"/>
-          </a:p>
-        </p:txBody>
-      </p:sp>
-      <p:sp>
-        <p:nvSpPr>
-          <p:cNvPr id="7" name="Slide Number Placeholder 6"/>
-          <p:cNvSpPr>
-            <a:spLocks noGrp="1"/>
-          </p:cNvSpPr>
-          <p:nvPr>
-            <p:ph type="sldNum" sz="quarter" idx="5"/>
-          </p:nvPr>
-        </p:nvSpPr>
-        <p:spPr>
-          <a:xfrm>
-            <a:off x="3884613" y="8685213"/>
-            <a:ext cx="2971800" cy="458787"/>
-          </a:xfrm>
-          <a:prstGeom prst="rect">
-            <a:avLst/>
-          </a:prstGeom>
-        </p:spPr>
-        <p:txBody>
-          <a:bodyPr vert="horz" lIns="91440" tIns="45720" rIns="91440" bIns="45720" rtlCol="0" anchor="b"/>
-          <a:lstStyle>
-            <a:lvl1pPr algn="r">
-              <a:defRPr sz="1200"/>
-            </a:lvl1pPr>
-          </a:lstStyle>
-          <a:p>
-            <a:fld id="{CE5E9CC1-C706-0F49-92D6-E571CC5EEA8F}" type="slidenum">
-              <a:rPr lang="en-US"/>
-              <a:t>‹#›</a:t>
-            </a:fld>
-            <a:endParaRPr lang="en-US"/>
-          </a:p>
-        </p:txBody>
-      </p:sp>
     </p:spTree>
     <p:extLst>
       <p:ext uri="{BB962C8B-B14F-4D97-AF65-F5344CB8AC3E}">
-        <p14:creationId xmlns:p14="http://schemas.microsoft.com/office/powerpoint/2010/main" val="1024086991"/>
+        <p14:creationId xmlns:p14="http://schemas.microsoft.com/office/powerpoint/2010/main" val="1765898314"/>
       </p:ext>
     </p:extLst>
   </p:cSld>
@@ -1879,7 +1293,6 @@
               <a:rPr lang="en-US" dirty="0"/>
               <a:t>We are FinTech Titans. Fraud here is one transaction in every 750, and that rarity shaped every decision we made.</a:t>
             </a:r>
-            <a:endParaRPr lang="en-US" dirty="0"/>
           </a:p>
         </p:txBody>
       </p:sp>
@@ -1967,7 +1380,6 @@
               <a:rPr lang="en-US" dirty="0"/>
               <a:t>This is the slide to linger on. Precision of 0.19 looks bad until you price it. The two mistakes are not equally expensive.</a:t>
             </a:r>
-            <a:endParaRPr lang="en-US" dirty="0"/>
           </a:p>
         </p:txBody>
       </p:sp>
@@ -2055,7 +1467,6 @@
               <a:rPr lang="en-US" dirty="0"/>
               <a:t>Each recommendation traces to a number in the report. The first alone removes more than half the scoring load.</a:t>
             </a:r>
-            <a:endParaRPr lang="en-US" dirty="0"/>
           </a:p>
         </p:txBody>
       </p:sp>
@@ -2143,7 +1554,6 @@
               <a:rPr lang="en-US" dirty="0"/>
               <a:t>Close on the leak. It is the finding that separates this submission from one that reports 0.99 and stops.</a:t>
             </a:r>
-            <a:endParaRPr lang="en-US" dirty="0"/>
           </a:p>
         </p:txBody>
       </p:sp>
@@ -2231,7 +1641,6 @@
               <a:rPr lang="en-US" dirty="0"/>
               <a:t>Accuracy is meaningless at this base rate. We judge on PR-AUC and on money. Note we rejected SMOTE, which our Phase 1 plan had proposed.</a:t>
             </a:r>
-            <a:endParaRPr lang="en-US" dirty="0"/>
           </a:p>
         </p:txBody>
       </p:sp>
@@ -2319,7 +1728,6 @@
               <a:rPr lang="en-US" dirty="0"/>
               <a:t>Fraud only ever appears in transfers and cash outs. Transfer carries four times the rate and is the first leg, so stopping it prevents the loss outright.</a:t>
             </a:r>
-            <a:endParaRPr lang="en-US" dirty="0"/>
           </a:p>
         </p:txBody>
       </p:sp>
@@ -2407,7 +1815,6 @@
               <a:rPr lang="en-US" dirty="0"/>
               <a:t>Real customers go quiet. Criminals do not. We deliberately avoid naming clock hours because the dataset never states when it began.</a:t>
             </a:r>
-            <a:endParaRPr lang="en-US" dirty="0"/>
           </a:p>
         </p:txBody>
       </p:sp>
@@ -2495,7 +1902,6 @@
               <a:rPr lang="en-US" dirty="0"/>
               <a:t>This is our most important finding. We measured the leak rather than hiding it, and chose the middle option, which uses only information available at the moment of decision.</a:t>
             </a:r>
-            <a:endParaRPr lang="en-US" dirty="0"/>
           </a:p>
         </p:txBody>
       </p:sp>
@@ -2583,7 +1989,6 @@
               <a:rPr lang="en-US" dirty="0"/>
               <a:t>Logistic regression is the baseline. Running three feature sets means we can see exactly where every gain comes from rather than quoting one number with no context.</a:t>
             </a:r>
-            <a:endParaRPr lang="en-US" dirty="0"/>
           </a:p>
         </p:txBody>
       </p:sp>
@@ -2671,7 +2076,6 @@
               <a:rPr lang="en-US" dirty="0"/>
               <a:t>XGBoost wins on every feature set. The baseline genuinely struggles, which justifies moving to tree ensembles rather than assuming it.</a:t>
             </a:r>
-            <a:endParaRPr lang="en-US" dirty="0"/>
           </a:p>
         </p:txBody>
       </p:sp>
@@ -2759,7 +2163,6 @@
               <a:rPr lang="en-US" dirty="0"/>
               <a:t>It would have been easy to spend the whole project on parameter tuning and gain nothing. We report this ordering deliberately.</a:t>
             </a:r>
-            <a:endParaRPr lang="en-US" dirty="0"/>
           </a:p>
         </p:txBody>
       </p:sp>
@@ -2847,7 +2250,6 @@
               <a:rPr lang="en-US" dirty="0"/>
               <a:t>Nine features, all computable before settlement. Explainability was also a diagnostic: it is how we proved the leaked columns were dominating the third feature set.</a:t>
             </a:r>
-            <a:endParaRPr lang="en-US" dirty="0"/>
           </a:p>
         </p:txBody>
       </p:sp>
@@ -2920,6 +2322,11 @@
 <file path=ppt/slideMasters/slideMaster1.xml><?xml version="1.0" encoding="utf-8"?>
 <p:sldMaster xmlns:a="http://schemas.openxmlformats.org/drawingml/2006/main" xmlns:r="http://schemas.openxmlformats.org/officeDocument/2006/relationships" xmlns:p="http://schemas.openxmlformats.org/presentationml/2006/main">
   <p:cSld>
+    <p:bg>
+      <p:bgRef idx="1001">
+        <a:schemeClr val="bg1"/>
+      </p:bgRef>
+    </p:bg>
     <p:spTree>
       <p:nvGrpSpPr>
         <p:cNvPr id="1" name=""/>
@@ -3202,6 +2609,7 @@
         <a:solidFill>
           <a:srgbClr val="0033A1"/>
         </a:solidFill>
+        <a:effectLst/>
       </p:bgPr>
     </p:bg>
     <p:spTree>
@@ -3239,11 +2647,11 @@
           <a:bodyPr wrap="square" rtlCol="0" anchor="ctr"/>
           <a:lstStyle/>
           <a:p>
-            <a:pPr indent="0" marL="0">
-              <a:buNone/>
-            </a:pPr>
-            <a:r>
-              <a:rPr lang="en-US" sz="1300" b="1" spc="200" kern="0" dirty="0">
+            <a:pPr marL="0" indent="0">
+              <a:buNone/>
+            </a:pPr>
+            <a:r>
+              <a:rPr lang="en-US" sz="1300" b="1" kern="0" spc="200" dirty="0">
                 <a:solidFill>
                   <a:srgbClr val="A8C0F0"/>
                 </a:solidFill>
@@ -3278,7 +2686,7 @@
           <a:bodyPr wrap="square" rtlCol="0" anchor="ctr"/>
           <a:lstStyle/>
           <a:p>
-            <a:pPr indent="0" marL="0">
+            <a:pPr marL="0" indent="0">
               <a:buNone/>
             </a:pPr>
             <a:r>
@@ -3317,7 +2725,7 @@
           <a:bodyPr wrap="square" rtlCol="0" anchor="ctr"/>
           <a:lstStyle/>
           <a:p>
-            <a:pPr indent="0" marL="0">
+            <a:pPr marL="0" indent="0">
               <a:buNone/>
             </a:pPr>
             <a:r>
@@ -3357,6 +2765,13 @@
             <a:prstDash val="solid"/>
           </a:ln>
         </p:spPr>
+        <p:txBody>
+          <a:bodyPr/>
+          <a:lstStyle/>
+          <a:p>
+            <a:endParaRPr lang="en-US"/>
+          </a:p>
+        </p:txBody>
       </p:sp>
       <p:sp>
         <p:nvSpPr>
@@ -3379,7 +2794,7 @@
           <a:bodyPr wrap="square" rtlCol="0" anchor="ctr"/>
           <a:lstStyle/>
           <a:p>
-            <a:pPr indent="0" marL="0">
+            <a:pPr marL="0" indent="0">
               <a:buNone/>
             </a:pPr>
             <a:r>
@@ -3418,7 +2833,7 @@
           <a:bodyPr wrap="square" rtlCol="0" anchor="ctr"/>
           <a:lstStyle/>
           <a:p>
-            <a:pPr indent="0" marL="0">
+            <a:pPr marL="0" indent="0">
               <a:buNone/>
             </a:pPr>
             <a:r>
@@ -3432,9 +2847,6 @@
               </a:rPr>
               <a:t>636,262 transactions</a:t>
             </a:r>
-            <a:pPr indent="0" marL="0">
-              <a:buNone/>
-            </a:pPr>
             <a:r>
               <a:rPr lang="en-US" sz="1400" dirty="0">
                 <a:solidFill>
@@ -3471,7 +2883,7 @@
           <a:bodyPr wrap="square" rtlCol="0" anchor="ctr"/>
           <a:lstStyle/>
           <a:p>
-            <a:pPr indent="0" marL="0">
+            <a:pPr marL="0" indent="0">
               <a:buNone/>
             </a:pPr>
             <a:r>
@@ -3505,6 +2917,7 @@
         <a:solidFill>
           <a:srgbClr val="FFFFFF"/>
         </a:solidFill>
+        <a:effectLst/>
       </p:bgPr>
     </p:bg>
     <p:spTree>
@@ -3542,7 +2955,7 @@
           <a:bodyPr wrap="square" rtlCol="0" anchor="ctr"/>
           <a:lstStyle/>
           <a:p>
-            <a:pPr indent="0" marL="0">
+            <a:pPr marL="0" indent="0">
               <a:buNone/>
             </a:pPr>
             <a:r>
@@ -3581,7 +2994,7 @@
           <a:bodyPr wrap="square" rtlCol="0" anchor="ctr"/>
           <a:lstStyle/>
           <a:p>
-            <a:pPr indent="0" marL="0">
+            <a:pPr marL="0" indent="0">
               <a:buNone/>
             </a:pPr>
             <a:r>
@@ -3620,7 +3033,7 @@
           <a:bodyPr wrap="square" rtlCol="0" anchor="ctr"/>
           <a:lstStyle/>
           <a:p>
-            <a:pPr algn="r" indent="0" marL="0">
+            <a:pPr marL="0" indent="0" algn="r">
               <a:buNone/>
             </a:pPr>
             <a:r>
@@ -3659,7 +3072,7 @@
           <a:bodyPr wrap="square" rtlCol="0" anchor="ctr"/>
           <a:lstStyle/>
           <a:p>
-            <a:pPr indent="0" marL="0">
+            <a:pPr marL="0" indent="0">
               <a:buNone/>
             </a:pPr>
             <a:r>
@@ -3679,7 +3092,7 @@
       </p:sp>
       <p:graphicFrame>
         <p:nvGraphicFramePr>
-          <p:cNvPr id="6" name="Chart 0" descr=""/>
+          <p:cNvPr id="6" name="Chart 0"/>
           <p:cNvGraphicFramePr/>
           <p:nvPr/>
         </p:nvGraphicFramePr>
@@ -3687,9 +3100,9 @@
           <a:off x="548640" y="1600200"/>
           <a:ext cx="6675120" cy="3017520"/>
         </p:xfrm>
-        <a:graphic xmlns:a="http://schemas.openxmlformats.org/drawingml/2006/main">
+        <a:graphic>
           <a:graphicData uri="http://schemas.openxmlformats.org/drawingml/2006/chart">
-            <c:chart xmlns:c="http://schemas.openxmlformats.org/drawingml/2006/chart" r:id="rId1"/>
+            <c:chart xmlns:c="http://schemas.openxmlformats.org/drawingml/2006/chart" xmlns:r="http://schemas.openxmlformats.org/officeDocument/2006/relationships" r:id="rId3"/>
           </a:graphicData>
         </a:graphic>
       </p:graphicFrame>
@@ -3714,7 +3127,7 @@
           <a:bodyPr wrap="square" rtlCol="0" anchor="ctr"/>
           <a:lstStyle/>
           <a:p>
-            <a:pPr indent="0" marL="0">
+            <a:pPr marL="0" indent="0">
               <a:buNone/>
             </a:pPr>
             <a:r>
@@ -3758,6 +3171,13 @@
             <a:prstDash val="solid"/>
           </a:ln>
         </p:spPr>
+        <p:txBody>
+          <a:bodyPr/>
+          <a:lstStyle/>
+          <a:p>
+            <a:endParaRPr lang="en-US"/>
+          </a:p>
+        </p:txBody>
       </p:sp>
       <p:sp>
         <p:nvSpPr>
@@ -3780,7 +3200,7 @@
           <a:bodyPr wrap="square" rtlCol="0" anchor="ctr"/>
           <a:lstStyle/>
           <a:p>
-            <a:pPr indent="0" marL="0">
+            <a:pPr marL="0" indent="0">
               <a:buNone/>
             </a:pPr>
             <a:r>
@@ -3819,7 +3239,7 @@
           <a:bodyPr wrap="square" rtlCol="0" anchor="ctr"/>
           <a:lstStyle/>
           <a:p>
-            <a:pPr indent="0" marL="0">
+            <a:pPr marL="0" indent="0">
               <a:buNone/>
             </a:pPr>
             <a:r>
@@ -3833,9 +3253,6 @@
               </a:rPr>
               <a:t>The cheapest option has precision of only </a:t>
             </a:r>
-            <a:pPr indent="0" marL="0">
-              <a:buNone/>
-            </a:pPr>
             <a:r>
               <a:rPr lang="en-US" sz="1250" b="1" dirty="0">
                 <a:solidFill>
@@ -3847,9 +3264,6 @@
               </a:rPr>
               <a:t>0.19</a:t>
             </a:r>
-            <a:pPr indent="0" marL="0">
-              <a:buNone/>
-            </a:pPr>
             <a:r>
               <a:rPr lang="en-US" sz="1250" dirty="0">
                 <a:solidFill>
@@ -3864,13 +3278,13 @@
             <a:endParaRPr lang="en-US" sz="1250" dirty="0"/>
           </a:p>
           <a:p>
-            <a:pPr indent="0" marL="0">
+            <a:pPr marL="0" indent="0">
               <a:buNone/>
             </a:pPr>
             <a:endParaRPr lang="en-US" sz="1250" dirty="0"/>
           </a:p>
           <a:p>
-            <a:pPr indent="0" marL="0">
+            <a:pPr marL="0" indent="0">
               <a:buNone/>
             </a:pPr>
             <a:r>
@@ -3887,7 +3301,7 @@
             <a:endParaRPr lang="en-US" sz="1250" dirty="0"/>
           </a:p>
           <a:p>
-            <a:pPr indent="0" marL="0">
+            <a:pPr marL="0" indent="0">
               <a:buNone/>
             </a:pPr>
             <a:r>
@@ -3901,9 +3315,6 @@
               </a:rPr>
               <a:t>96 percent</a:t>
             </a:r>
-            <a:pPr indent="0" marL="0">
-              <a:buNone/>
-            </a:pPr>
             <a:r>
               <a:rPr lang="en-US" sz="1250" dirty="0">
                 <a:solidFill>
@@ -3918,13 +3329,13 @@
             <a:endParaRPr lang="en-US" sz="1250" dirty="0"/>
           </a:p>
           <a:p>
-            <a:pPr indent="0" marL="0">
+            <a:pPr marL="0" indent="0">
               <a:buNone/>
             </a:pPr>
             <a:endParaRPr lang="en-US" sz="1250" dirty="0"/>
           </a:p>
           <a:p>
-            <a:pPr indent="0" marL="0">
+            <a:pPr marL="0" indent="0">
               <a:buNone/>
             </a:pPr>
             <a:r>
@@ -3941,7 +3352,7 @@
             <a:endParaRPr lang="en-US" sz="1250" dirty="0"/>
           </a:p>
           <a:p>
-            <a:pPr indent="0" marL="0">
+            <a:pPr marL="0" indent="0">
               <a:buNone/>
             </a:pPr>
             <a:r>
@@ -3955,9 +3366,6 @@
               </a:rPr>
               <a:t>R245,050 more</a:t>
             </a:r>
-            <a:pPr indent="0" marL="0">
-              <a:buNone/>
-            </a:pPr>
             <a:r>
               <a:rPr lang="en-US" sz="1250" dirty="0">
                 <a:solidFill>
@@ -3999,6 +3407,13 @@
             <a:prstDash val="solid"/>
           </a:ln>
         </p:spPr>
+        <p:txBody>
+          <a:bodyPr/>
+          <a:lstStyle/>
+          <a:p>
+            <a:endParaRPr lang="en-US"/>
+          </a:p>
+        </p:txBody>
       </p:sp>
       <p:sp>
         <p:nvSpPr>
@@ -4021,7 +3436,7 @@
           <a:bodyPr wrap="square" rtlCol="0" anchor="ctr"/>
           <a:lstStyle/>
           <a:p>
-            <a:pPr indent="0" marL="0">
+            <a:pPr marL="0" indent="0">
               <a:buNone/>
             </a:pPr>
             <a:r>
@@ -4035,9 +3450,6 @@
               </a:rPr>
               <a:t>Because a missed fraud costs 100 times more than a wasted review, the bank should deliberately accept a high false alarm rate. </a:t>
             </a:r>
-            <a:pPr indent="0" marL="0">
-              <a:buNone/>
-            </a:pPr>
             <a:r>
               <a:rPr lang="en-US" sz="1300" b="1" dirty="0">
                 <a:solidFill>
@@ -4069,6 +3481,7 @@
         <a:solidFill>
           <a:srgbClr val="FFFFFF"/>
         </a:solidFill>
+        <a:effectLst/>
       </p:bgPr>
     </p:bg>
     <p:spTree>
@@ -4106,7 +3519,7 @@
           <a:bodyPr wrap="square" rtlCol="0" anchor="ctr"/>
           <a:lstStyle/>
           <a:p>
-            <a:pPr indent="0" marL="0">
+            <a:pPr marL="0" indent="0">
               <a:buNone/>
             </a:pPr>
             <a:r>
@@ -4145,7 +3558,7 @@
           <a:bodyPr wrap="square" rtlCol="0" anchor="ctr"/>
           <a:lstStyle/>
           <a:p>
-            <a:pPr indent="0" marL="0">
+            <a:pPr marL="0" indent="0">
               <a:buNone/>
             </a:pPr>
             <a:r>
@@ -4184,7 +3597,7 @@
           <a:bodyPr wrap="square" rtlCol="0" anchor="ctr"/>
           <a:lstStyle/>
           <a:p>
-            <a:pPr algn="r" indent="0" marL="0">
+            <a:pPr marL="0" indent="0" algn="r">
               <a:buNone/>
             </a:pPr>
             <a:r>
@@ -4223,7 +3636,7 @@
           <a:bodyPr wrap="square" rtlCol="0" anchor="ctr"/>
           <a:lstStyle/>
           <a:p>
-            <a:pPr indent="0" marL="0">
+            <a:pPr marL="0" indent="0">
               <a:buNone/>
             </a:pPr>
             <a:r>
@@ -4267,6 +3680,13 @@
             <a:prstDash val="solid"/>
           </a:ln>
         </p:spPr>
+        <p:txBody>
+          <a:bodyPr/>
+          <a:lstStyle/>
+          <a:p>
+            <a:endParaRPr lang="en-US"/>
+          </a:p>
+        </p:txBody>
       </p:sp>
       <p:sp>
         <p:nvSpPr>
@@ -4289,7 +3709,7 @@
           <a:bodyPr wrap="square" rtlCol="0" anchor="ctr"/>
           <a:lstStyle/>
           <a:p>
-            <a:pPr indent="0" marL="0">
+            <a:pPr marL="0" indent="0">
               <a:buNone/>
             </a:pPr>
             <a:r>
@@ -4328,7 +3748,7 @@
           <a:bodyPr wrap="square" rtlCol="0" anchor="ctr"/>
           <a:lstStyle/>
           <a:p>
-            <a:pPr indent="0" marL="0">
+            <a:pPr marL="0" indent="0">
               <a:buNone/>
             </a:pPr>
             <a:r>
@@ -4367,7 +3787,7 @@
           <a:bodyPr wrap="square" rtlCol="0" anchor="ctr"/>
           <a:lstStyle/>
           <a:p>
-            <a:pPr indent="0" marL="0">
+            <a:pPr marL="0" indent="0">
               <a:buNone/>
             </a:pPr>
             <a:r>
@@ -4411,6 +3831,13 @@
             <a:prstDash val="solid"/>
           </a:ln>
         </p:spPr>
+        <p:txBody>
+          <a:bodyPr/>
+          <a:lstStyle/>
+          <a:p>
+            <a:endParaRPr lang="en-US"/>
+          </a:p>
+        </p:txBody>
       </p:sp>
       <p:sp>
         <p:nvSpPr>
@@ -4433,7 +3860,7 @@
           <a:bodyPr wrap="square" rtlCol="0" anchor="ctr"/>
           <a:lstStyle/>
           <a:p>
-            <a:pPr indent="0" marL="0">
+            <a:pPr marL="0" indent="0">
               <a:buNone/>
             </a:pPr>
             <a:r>
@@ -4472,7 +3899,7 @@
           <a:bodyPr wrap="square" rtlCol="0" anchor="ctr"/>
           <a:lstStyle/>
           <a:p>
-            <a:pPr indent="0" marL="0">
+            <a:pPr marL="0" indent="0">
               <a:buNone/>
             </a:pPr>
             <a:r>
@@ -4511,7 +3938,7 @@
           <a:bodyPr wrap="square" rtlCol="0" anchor="ctr"/>
           <a:lstStyle/>
           <a:p>
-            <a:pPr indent="0" marL="0">
+            <a:pPr marL="0" indent="0">
               <a:buNone/>
             </a:pPr>
             <a:r>
@@ -4555,6 +3982,13 @@
             <a:prstDash val="solid"/>
           </a:ln>
         </p:spPr>
+        <p:txBody>
+          <a:bodyPr/>
+          <a:lstStyle/>
+          <a:p>
+            <a:endParaRPr lang="en-US"/>
+          </a:p>
+        </p:txBody>
       </p:sp>
       <p:sp>
         <p:nvSpPr>
@@ -4577,7 +4011,7 @@
           <a:bodyPr wrap="square" rtlCol="0" anchor="ctr"/>
           <a:lstStyle/>
           <a:p>
-            <a:pPr indent="0" marL="0">
+            <a:pPr marL="0" indent="0">
               <a:buNone/>
             </a:pPr>
             <a:r>
@@ -4616,7 +4050,7 @@
           <a:bodyPr wrap="square" rtlCol="0" anchor="ctr"/>
           <a:lstStyle/>
           <a:p>
-            <a:pPr indent="0" marL="0">
+            <a:pPr marL="0" indent="0">
               <a:buNone/>
             </a:pPr>
             <a:r>
@@ -4655,7 +4089,7 @@
           <a:bodyPr wrap="square" rtlCol="0" anchor="ctr"/>
           <a:lstStyle/>
           <a:p>
-            <a:pPr indent="0" marL="0">
+            <a:pPr marL="0" indent="0">
               <a:buNone/>
             </a:pPr>
             <a:r>
@@ -4699,6 +4133,13 @@
             <a:prstDash val="solid"/>
           </a:ln>
         </p:spPr>
+        <p:txBody>
+          <a:bodyPr/>
+          <a:lstStyle/>
+          <a:p>
+            <a:endParaRPr lang="en-US"/>
+          </a:p>
+        </p:txBody>
       </p:sp>
       <p:sp>
         <p:nvSpPr>
@@ -4721,7 +4162,7 @@
           <a:bodyPr wrap="square" rtlCol="0" anchor="ctr"/>
           <a:lstStyle/>
           <a:p>
-            <a:pPr indent="0" marL="0">
+            <a:pPr marL="0" indent="0">
               <a:buNone/>
             </a:pPr>
             <a:r>
@@ -4760,7 +4201,7 @@
           <a:bodyPr wrap="square" rtlCol="0" anchor="ctr"/>
           <a:lstStyle/>
           <a:p>
-            <a:pPr indent="0" marL="0">
+            <a:pPr marL="0" indent="0">
               <a:buNone/>
             </a:pPr>
             <a:r>
@@ -4799,7 +4240,7 @@
           <a:bodyPr wrap="square" rtlCol="0" anchor="ctr"/>
           <a:lstStyle/>
           <a:p>
-            <a:pPr indent="0" marL="0">
+            <a:pPr marL="0" indent="0">
               <a:buNone/>
             </a:pPr>
             <a:r>
@@ -4843,6 +4284,13 @@
             <a:prstDash val="solid"/>
           </a:ln>
         </p:spPr>
+        <p:txBody>
+          <a:bodyPr/>
+          <a:lstStyle/>
+          <a:p>
+            <a:endParaRPr lang="en-US"/>
+          </a:p>
+        </p:txBody>
       </p:sp>
       <p:sp>
         <p:nvSpPr>
@@ -4865,7 +4313,7 @@
           <a:bodyPr wrap="square" rtlCol="0" anchor="ctr"/>
           <a:lstStyle/>
           <a:p>
-            <a:pPr indent="0" marL="0">
+            <a:pPr marL="0" indent="0">
               <a:buNone/>
             </a:pPr>
             <a:r>
@@ -4904,7 +4352,7 @@
           <a:bodyPr wrap="square" rtlCol="0" anchor="ctr"/>
           <a:lstStyle/>
           <a:p>
-            <a:pPr indent="0" marL="0">
+            <a:pPr marL="0" indent="0">
               <a:buNone/>
             </a:pPr>
             <a:r>
@@ -4943,7 +4391,7 @@
           <a:bodyPr wrap="square" rtlCol="0" anchor="ctr"/>
           <a:lstStyle/>
           <a:p>
-            <a:pPr indent="0" marL="0">
+            <a:pPr marL="0" indent="0">
               <a:buNone/>
             </a:pPr>
             <a:r>
@@ -4987,6 +4435,13 @@
             <a:prstDash val="solid"/>
           </a:ln>
         </p:spPr>
+        <p:txBody>
+          <a:bodyPr/>
+          <a:lstStyle/>
+          <a:p>
+            <a:endParaRPr lang="en-US"/>
+          </a:p>
+        </p:txBody>
       </p:sp>
       <p:sp>
         <p:nvSpPr>
@@ -5009,7 +4464,7 @@
           <a:bodyPr wrap="square" rtlCol="0" anchor="ctr"/>
           <a:lstStyle/>
           <a:p>
-            <a:pPr indent="0" marL="0">
+            <a:pPr marL="0" indent="0">
               <a:buNone/>
             </a:pPr>
             <a:r>
@@ -5048,7 +4503,7 @@
           <a:bodyPr wrap="square" rtlCol="0" anchor="ctr"/>
           <a:lstStyle/>
           <a:p>
-            <a:pPr indent="0" marL="0">
+            <a:pPr marL="0" indent="0">
               <a:buNone/>
             </a:pPr>
             <a:r>
@@ -5087,7 +4542,7 @@
           <a:bodyPr wrap="square" rtlCol="0" anchor="ctr"/>
           <a:lstStyle/>
           <a:p>
-            <a:pPr indent="0" marL="0">
+            <a:pPr marL="0" indent="0">
               <a:buNone/>
             </a:pPr>
             <a:r>
@@ -5121,6 +4576,7 @@
         <a:solidFill>
           <a:srgbClr val="0033A1"/>
         </a:solidFill>
+        <a:effectLst/>
       </p:bgPr>
     </p:bg>
     <p:spTree>
@@ -5158,11 +4614,11 @@
           <a:bodyPr wrap="square" rtlCol="0" anchor="ctr"/>
           <a:lstStyle/>
           <a:p>
-            <a:pPr indent="0" marL="0">
-              <a:buNone/>
-            </a:pPr>
-            <a:r>
-              <a:rPr lang="en-US" sz="1300" b="1" spc="200" kern="0" dirty="0">
+            <a:pPr marL="0" indent="0">
+              <a:buNone/>
+            </a:pPr>
+            <a:r>
+              <a:rPr lang="en-US" sz="1300" b="1" kern="0" spc="200" dirty="0">
                 <a:solidFill>
                   <a:srgbClr val="A8C0F0"/>
                 </a:solidFill>
@@ -5197,7 +4653,7 @@
           <a:bodyPr wrap="square" rtlCol="0" anchor="ctr"/>
           <a:lstStyle/>
           <a:p>
-            <a:pPr indent="0" marL="0">
+            <a:pPr marL="0" indent="0">
               <a:buNone/>
             </a:pPr>
             <a:r>
@@ -5241,6 +4697,13 @@
             <a:prstDash val="solid"/>
           </a:ln>
         </p:spPr>
+        <p:txBody>
+          <a:bodyPr/>
+          <a:lstStyle/>
+          <a:p>
+            <a:endParaRPr lang="en-US"/>
+          </a:p>
+        </p:txBody>
       </p:sp>
       <p:sp>
         <p:nvSpPr>
@@ -5263,7 +4726,7 @@
           <a:bodyPr wrap="square" rtlCol="0" anchor="ctr"/>
           <a:lstStyle/>
           <a:p>
-            <a:pPr indent="0" marL="0">
+            <a:pPr marL="0" indent="0">
               <a:buNone/>
             </a:pPr>
             <a:r>
@@ -5302,7 +4765,7 @@
           <a:bodyPr wrap="square" rtlCol="0" anchor="ctr"/>
           <a:lstStyle/>
           <a:p>
-            <a:pPr indent="0" marL="0">
+            <a:pPr marL="0" indent="0">
               <a:buNone/>
             </a:pPr>
             <a:r>
@@ -5346,6 +4809,13 @@
             <a:prstDash val="solid"/>
           </a:ln>
         </p:spPr>
+        <p:txBody>
+          <a:bodyPr/>
+          <a:lstStyle/>
+          <a:p>
+            <a:endParaRPr lang="en-US"/>
+          </a:p>
+        </p:txBody>
       </p:sp>
       <p:sp>
         <p:nvSpPr>
@@ -5368,7 +4838,7 @@
           <a:bodyPr wrap="square" rtlCol="0" anchor="ctr"/>
           <a:lstStyle/>
           <a:p>
-            <a:pPr indent="0" marL="0">
+            <a:pPr marL="0" indent="0">
               <a:buNone/>
             </a:pPr>
             <a:r>
@@ -5407,7 +4877,7 @@
           <a:bodyPr wrap="square" rtlCol="0" anchor="ctr"/>
           <a:lstStyle/>
           <a:p>
-            <a:pPr indent="0" marL="0">
+            <a:pPr marL="0" indent="0">
               <a:buNone/>
             </a:pPr>
             <a:r>
@@ -5451,6 +4921,13 @@
             <a:prstDash val="solid"/>
           </a:ln>
         </p:spPr>
+        <p:txBody>
+          <a:bodyPr/>
+          <a:lstStyle/>
+          <a:p>
+            <a:endParaRPr lang="en-US"/>
+          </a:p>
+        </p:txBody>
       </p:sp>
       <p:sp>
         <p:nvSpPr>
@@ -5473,7 +4950,7 @@
           <a:bodyPr wrap="square" rtlCol="0" anchor="ctr"/>
           <a:lstStyle/>
           <a:p>
-            <a:pPr indent="0" marL="0">
+            <a:pPr marL="0" indent="0">
               <a:buNone/>
             </a:pPr>
             <a:r>
@@ -5512,7 +4989,7 @@
           <a:bodyPr wrap="square" rtlCol="0" anchor="ctr"/>
           <a:lstStyle/>
           <a:p>
-            <a:pPr indent="0" marL="0">
+            <a:pPr marL="0" indent="0">
               <a:buNone/>
             </a:pPr>
             <a:r>
@@ -5551,7 +5028,7 @@
           <a:bodyPr wrap="square" rtlCol="0" anchor="ctr"/>
           <a:lstStyle/>
           <a:p>
-            <a:pPr indent="0" marL="0">
+            <a:pPr marL="0" indent="0">
               <a:buNone/>
             </a:pPr>
             <a:r>
@@ -5565,9 +5042,6 @@
               </a:rPr>
               <a:t>The finding we would put first:  </a:t>
             </a:r>
-            <a:pPr indent="0" marL="0">
-              <a:buNone/>
-            </a:pPr>
             <a:r>
               <a:rPr lang="en-US" sz="1400" dirty="0">
                 <a:solidFill>
@@ -5605,6 +5079,13 @@
             <a:prstDash val="solid"/>
           </a:ln>
         </p:spPr>
+        <p:txBody>
+          <a:bodyPr/>
+          <a:lstStyle/>
+          <a:p>
+            <a:endParaRPr lang="en-US"/>
+          </a:p>
+        </p:txBody>
       </p:sp>
       <p:sp>
         <p:nvSpPr>
@@ -5627,7 +5108,7 @@
           <a:bodyPr wrap="square" rtlCol="0" anchor="ctr"/>
           <a:lstStyle/>
           <a:p>
-            <a:pPr indent="0" marL="0">
+            <a:pPr marL="0" indent="0">
               <a:buNone/>
             </a:pPr>
             <a:r>
@@ -5666,7 +5147,7 @@
           <a:bodyPr wrap="square" rtlCol="0" anchor="ctr"/>
           <a:lstStyle/>
           <a:p>
-            <a:pPr algn="r" indent="0" marL="0">
+            <a:pPr marL="0" indent="0" algn="r">
               <a:buNone/>
             </a:pPr>
             <a:r>
@@ -5700,6 +5181,7 @@
         <a:solidFill>
           <a:srgbClr val="FFFFFF"/>
         </a:solidFill>
+        <a:effectLst/>
       </p:bgPr>
     </p:bg>
     <p:spTree>
@@ -5737,7 +5219,7 @@
           <a:bodyPr wrap="square" rtlCol="0" anchor="ctr"/>
           <a:lstStyle/>
           <a:p>
-            <a:pPr indent="0" marL="0">
+            <a:pPr marL="0" indent="0">
               <a:buNone/>
             </a:pPr>
             <a:r>
@@ -5776,7 +5258,7 @@
           <a:bodyPr wrap="square" rtlCol="0" anchor="ctr"/>
           <a:lstStyle/>
           <a:p>
-            <a:pPr indent="0" marL="0">
+            <a:pPr marL="0" indent="0">
               <a:buNone/>
             </a:pPr>
             <a:r>
@@ -5815,7 +5297,7 @@
           <a:bodyPr wrap="square" rtlCol="0" anchor="ctr"/>
           <a:lstStyle/>
           <a:p>
-            <a:pPr algn="r" indent="0" marL="0">
+            <a:pPr marL="0" indent="0" algn="r">
               <a:buNone/>
             </a:pPr>
             <a:r>
@@ -5854,7 +5336,7 @@
           <a:bodyPr wrap="square" rtlCol="0" anchor="ctr"/>
           <a:lstStyle/>
           <a:p>
-            <a:pPr indent="0" marL="0">
+            <a:pPr marL="0" indent="0">
               <a:buNone/>
             </a:pPr>
             <a:r>
@@ -5874,7 +5356,7 @@
       </p:sp>
       <p:graphicFrame>
         <p:nvGraphicFramePr>
-          <p:cNvPr id="6" name="Chart 0" descr=""/>
+          <p:cNvPr id="6" name="Chart 0"/>
           <p:cNvGraphicFramePr/>
           <p:nvPr/>
         </p:nvGraphicFramePr>
@@ -5882,9 +5364,9 @@
           <a:off x="548640" y="1508760"/>
           <a:ext cx="4297680" cy="3840480"/>
         </p:xfrm>
-        <a:graphic xmlns:a="http://schemas.openxmlformats.org/drawingml/2006/main">
+        <a:graphic>
           <a:graphicData uri="http://schemas.openxmlformats.org/drawingml/2006/chart">
-            <c:chart xmlns:c="http://schemas.openxmlformats.org/drawingml/2006/chart" r:id="rId1"/>
+            <c:chart xmlns:c="http://schemas.openxmlformats.org/drawingml/2006/chart" xmlns:r="http://schemas.openxmlformats.org/officeDocument/2006/relationships" r:id="rId3"/>
           </a:graphicData>
         </a:graphic>
       </p:graphicFrame>
@@ -5909,7 +5391,7 @@
           <a:bodyPr wrap="square" rtlCol="0" anchor="ctr"/>
           <a:lstStyle/>
           <a:p>
-            <a:pPr algn="ctr" indent="0" marL="0">
+            <a:pPr marL="0" indent="0" algn="ctr">
               <a:buNone/>
             </a:pPr>
             <a:r>
@@ -5948,7 +5430,7 @@
           <a:bodyPr wrap="square" rtlCol="0" anchor="ctr"/>
           <a:lstStyle/>
           <a:p>
-            <a:pPr algn="ctr" indent="0" marL="0">
+            <a:pPr marL="0" indent="0" algn="ctr">
               <a:buNone/>
             </a:pPr>
             <a:r>
@@ -5992,6 +5474,13 @@
             <a:prstDash val="solid"/>
           </a:ln>
         </p:spPr>
+        <p:txBody>
+          <a:bodyPr/>
+          <a:lstStyle/>
+          <a:p>
+            <a:endParaRPr lang="en-US"/>
+          </a:p>
+        </p:txBody>
       </p:sp>
       <p:sp>
         <p:nvSpPr>
@@ -6014,7 +5503,7 @@
           <a:bodyPr wrap="square" rtlCol="0" anchor="ctr"/>
           <a:lstStyle/>
           <a:p>
-            <a:pPr indent="0" marL="0">
+            <a:pPr marL="0" indent="0">
               <a:buNone/>
             </a:pPr>
             <a:r>
@@ -6053,7 +5542,7 @@
           <a:bodyPr wrap="square" rtlCol="0" anchor="ctr"/>
           <a:lstStyle/>
           <a:p>
-            <a:pPr indent="0" marL="0">
+            <a:pPr marL="0" indent="0">
               <a:buNone/>
             </a:pPr>
             <a:r>
@@ -6092,7 +5581,7 @@
           <a:bodyPr wrap="square" rtlCol="0" anchor="ctr"/>
           <a:lstStyle/>
           <a:p>
-            <a:pPr indent="0" marL="0">
+            <a:pPr marL="0" indent="0">
               <a:buNone/>
             </a:pPr>
             <a:r>
@@ -6131,7 +5620,7 @@
           <a:bodyPr wrap="square" rtlCol="0" anchor="ctr"/>
           <a:lstStyle/>
           <a:p>
-            <a:pPr indent="0" marL="0">
+            <a:pPr marL="0" indent="0">
               <a:lnSpc>
                 <a:spcPts val="2300"/>
               </a:lnSpc>
@@ -6148,12 +5637,6 @@
               </a:rPr>
               <a:t>PR-AUC</a:t>
             </a:r>
-            <a:pPr indent="0" marL="0">
-              <a:lnSpc>
-                <a:spcPts val="2300"/>
-              </a:lnSpc>
-              <a:buNone/>
-            </a:pPr>
             <a:r>
               <a:rPr lang="en-US" sz="1300" dirty="0">
                 <a:solidFill>
@@ -6166,12 +5649,6 @@
               <a:t>   how well the model ranks rare positives
 </a:t>
             </a:r>
-            <a:pPr indent="0" marL="0">
-              <a:lnSpc>
-                <a:spcPts val="2300"/>
-              </a:lnSpc>
-              <a:buNone/>
-            </a:pPr>
             <a:r>
               <a:rPr lang="en-US" sz="1300" b="1" dirty="0">
                 <a:solidFill>
@@ -6183,12 +5660,6 @@
               </a:rPr>
               <a:t>Precision and recall</a:t>
             </a:r>
-            <a:pPr indent="0" marL="0">
-              <a:lnSpc>
-                <a:spcPts val="2300"/>
-              </a:lnSpc>
-              <a:buNone/>
-            </a:pPr>
             <a:r>
               <a:rPr lang="en-US" sz="1300" dirty="0">
                 <a:solidFill>
@@ -6201,12 +5672,6 @@
               <a:t>   at a chosen cut off
 </a:t>
             </a:r>
-            <a:pPr indent="0" marL="0">
-              <a:lnSpc>
-                <a:spcPts val="2300"/>
-              </a:lnSpc>
-              <a:buNone/>
-            </a:pPr>
             <a:r>
               <a:rPr lang="en-US" sz="1300" b="1" dirty="0">
                 <a:solidFill>
@@ -6218,12 +5683,6 @@
               </a:rPr>
               <a:t>Total cost in rand</a:t>
             </a:r>
-            <a:pPr indent="0" marL="0">
-              <a:lnSpc>
-                <a:spcPts val="2300"/>
-              </a:lnSpc>
-              <a:buNone/>
-            </a:pPr>
             <a:r>
               <a:rPr lang="en-US" sz="1300" dirty="0">
                 <a:solidFill>
@@ -6265,6 +5724,13 @@
             <a:prstDash val="solid"/>
           </a:ln>
         </p:spPr>
+        <p:txBody>
+          <a:bodyPr/>
+          <a:lstStyle/>
+          <a:p>
+            <a:endParaRPr lang="en-US"/>
+          </a:p>
+        </p:txBody>
       </p:sp>
       <p:sp>
         <p:nvSpPr>
@@ -6287,7 +5753,7 @@
           <a:bodyPr wrap="square" rtlCol="0" anchor="ctr"/>
           <a:lstStyle/>
           <a:p>
-            <a:pPr indent="0" marL="0">
+            <a:pPr marL="0" indent="0">
               <a:buNone/>
             </a:pPr>
             <a:r>
@@ -6301,9 +5767,6 @@
               </a:rPr>
               <a:t>On imbalance:  </a:t>
             </a:r>
-            <a:pPr indent="0" marL="0">
-              <a:buNone/>
-            </a:pPr>
             <a:r>
               <a:rPr lang="en-US" sz="1200" dirty="0">
                 <a:solidFill>
@@ -6335,6 +5798,7 @@
         <a:solidFill>
           <a:srgbClr val="FFFFFF"/>
         </a:solidFill>
+        <a:effectLst/>
       </p:bgPr>
     </p:bg>
     <p:spTree>
@@ -6372,7 +5836,7 @@
           <a:bodyPr wrap="square" rtlCol="0" anchor="ctr"/>
           <a:lstStyle/>
           <a:p>
-            <a:pPr indent="0" marL="0">
+            <a:pPr marL="0" indent="0">
               <a:buNone/>
             </a:pPr>
             <a:r>
@@ -6411,7 +5875,7 @@
           <a:bodyPr wrap="square" rtlCol="0" anchor="ctr"/>
           <a:lstStyle/>
           <a:p>
-            <a:pPr indent="0" marL="0">
+            <a:pPr marL="0" indent="0">
               <a:buNone/>
             </a:pPr>
             <a:r>
@@ -6450,7 +5914,7 @@
           <a:bodyPr wrap="square" rtlCol="0" anchor="ctr"/>
           <a:lstStyle/>
           <a:p>
-            <a:pPr algn="r" indent="0" marL="0">
+            <a:pPr marL="0" indent="0" algn="r">
               <a:buNone/>
             </a:pPr>
             <a:r>
@@ -6489,7 +5953,7 @@
           <a:bodyPr wrap="square" rtlCol="0" anchor="ctr"/>
           <a:lstStyle/>
           <a:p>
-            <a:pPr indent="0" marL="0">
+            <a:pPr marL="0" indent="0">
               <a:buNone/>
             </a:pPr>
             <a:r>
@@ -6509,7 +5973,7 @@
       </p:sp>
       <p:graphicFrame>
         <p:nvGraphicFramePr>
-          <p:cNvPr id="6" name="Chart 0" descr=""/>
+          <p:cNvPr id="6" name="Chart 0"/>
           <p:cNvGraphicFramePr/>
           <p:nvPr/>
         </p:nvGraphicFramePr>
@@ -6517,9 +5981,9 @@
           <a:off x="548640" y="1554480"/>
           <a:ext cx="6126480" cy="3657600"/>
         </p:xfrm>
-        <a:graphic xmlns:a="http://schemas.openxmlformats.org/drawingml/2006/main">
+        <a:graphic>
           <a:graphicData uri="http://schemas.openxmlformats.org/drawingml/2006/chart">
-            <c:chart xmlns:c="http://schemas.openxmlformats.org/drawingml/2006/chart" r:id="rId1"/>
+            <c:chart xmlns:c="http://schemas.openxmlformats.org/drawingml/2006/chart" xmlns:r="http://schemas.openxmlformats.org/officeDocument/2006/relationships" r:id="rId3"/>
           </a:graphicData>
         </a:graphic>
       </p:graphicFrame>
@@ -6549,6 +6013,13 @@
             <a:prstDash val="solid"/>
           </a:ln>
         </p:spPr>
+        <p:txBody>
+          <a:bodyPr/>
+          <a:lstStyle/>
+          <a:p>
+            <a:endParaRPr lang="en-US"/>
+          </a:p>
+        </p:txBody>
       </p:sp>
       <p:sp>
         <p:nvSpPr>
@@ -6571,7 +6042,7 @@
           <a:bodyPr wrap="square" rtlCol="0" anchor="ctr"/>
           <a:lstStyle/>
           <a:p>
-            <a:pPr algn="ctr" indent="0" marL="0">
+            <a:pPr marL="0" indent="0" algn="ctr">
               <a:buNone/>
             </a:pPr>
             <a:r>
@@ -6610,7 +6081,7 @@
           <a:bodyPr wrap="square" rtlCol="0" anchor="ctr"/>
           <a:lstStyle/>
           <a:p>
-            <a:pPr algn="ctr" indent="0" marL="0">
+            <a:pPr marL="0" indent="0" algn="ctr">
               <a:buNone/>
             </a:pPr>
             <a:r>
@@ -6627,7 +6098,7 @@
             <a:endParaRPr lang="en-US" sz="1100" dirty="0"/>
           </a:p>
           <a:p>
-            <a:pPr algn="ctr" indent="0" marL="0">
+            <a:pPr marL="0" indent="0" algn="ctr">
               <a:buNone/>
             </a:pPr>
             <a:r>
@@ -6671,6 +6142,13 @@
             <a:prstDash val="solid"/>
           </a:ln>
         </p:spPr>
+        <p:txBody>
+          <a:bodyPr/>
+          <a:lstStyle/>
+          <a:p>
+            <a:endParaRPr lang="en-US"/>
+          </a:p>
+        </p:txBody>
       </p:sp>
       <p:sp>
         <p:nvSpPr>
@@ -6693,7 +6171,7 @@
           <a:bodyPr wrap="square" rtlCol="0" anchor="ctr"/>
           <a:lstStyle/>
           <a:p>
-            <a:pPr algn="ctr" indent="0" marL="0">
+            <a:pPr marL="0" indent="0" algn="ctr">
               <a:buNone/>
             </a:pPr>
             <a:r>
@@ -6732,7 +6210,7 @@
           <a:bodyPr wrap="square" rtlCol="0" anchor="ctr"/>
           <a:lstStyle/>
           <a:p>
-            <a:pPr algn="ctr" indent="0" marL="0">
+            <a:pPr marL="0" indent="0" algn="ctr">
               <a:buNone/>
             </a:pPr>
             <a:r>
@@ -6749,7 +6227,7 @@
             <a:endParaRPr lang="en-US" sz="1100" dirty="0"/>
           </a:p>
           <a:p>
-            <a:pPr algn="ctr" indent="0" marL="0">
+            <a:pPr marL="0" indent="0" algn="ctr">
               <a:buNone/>
             </a:pPr>
             <a:r>
@@ -6793,6 +6271,13 @@
             <a:prstDash val="solid"/>
           </a:ln>
         </p:spPr>
+        <p:txBody>
+          <a:bodyPr/>
+          <a:lstStyle/>
+          <a:p>
+            <a:endParaRPr lang="en-US"/>
+          </a:p>
+        </p:txBody>
       </p:sp>
       <p:sp>
         <p:nvSpPr>
@@ -6815,7 +6300,7 @@
           <a:bodyPr wrap="square" rtlCol="0" anchor="ctr"/>
           <a:lstStyle/>
           <a:p>
-            <a:pPr indent="0" marL="0">
+            <a:pPr marL="0" indent="0">
               <a:buNone/>
             </a:pPr>
             <a:r>
@@ -6854,7 +6339,7 @@
           <a:bodyPr wrap="square" rtlCol="0" anchor="ctr"/>
           <a:lstStyle/>
           <a:p>
-            <a:pPr indent="0" marL="0">
+            <a:pPr marL="0" indent="0">
               <a:buNone/>
             </a:pPr>
             <a:r>
@@ -6868,9 +6353,6 @@
               </a:rPr>
               <a:t>PAYMENT, CASH_IN and DEBIT contain </a:t>
             </a:r>
-            <a:pPr indent="0" marL="0">
-              <a:buNone/>
-            </a:pPr>
             <a:r>
               <a:rPr lang="en-US" sz="1300" b="1" dirty="0">
                 <a:solidFill>
@@ -6882,9 +6364,6 @@
               </a:rPr>
               <a:t>zero fraud</a:t>
             </a:r>
-            <a:pPr indent="0" marL="0">
-              <a:buNone/>
-            </a:pPr>
             <a:r>
               <a:rPr lang="en-US" sz="1300" dirty="0">
                 <a:solidFill>
@@ -6921,7 +6400,7 @@
           <a:bodyPr wrap="square" rtlCol="0" anchor="ctr"/>
           <a:lstStyle/>
           <a:p>
-            <a:pPr indent="0" marL="0">
+            <a:pPr marL="0" indent="0">
               <a:buNone/>
             </a:pPr>
             <a:r>
@@ -6955,6 +6434,7 @@
         <a:solidFill>
           <a:srgbClr val="FFFFFF"/>
         </a:solidFill>
+        <a:effectLst/>
       </p:bgPr>
     </p:bg>
     <p:spTree>
@@ -6992,7 +6472,7 @@
           <a:bodyPr wrap="square" rtlCol="0" anchor="ctr"/>
           <a:lstStyle/>
           <a:p>
-            <a:pPr indent="0" marL="0">
+            <a:pPr marL="0" indent="0">
               <a:buNone/>
             </a:pPr>
             <a:r>
@@ -7031,7 +6511,7 @@
           <a:bodyPr wrap="square" rtlCol="0" anchor="ctr"/>
           <a:lstStyle/>
           <a:p>
-            <a:pPr indent="0" marL="0">
+            <a:pPr marL="0" indent="0">
               <a:buNone/>
             </a:pPr>
             <a:r>
@@ -7070,7 +6550,7 @@
           <a:bodyPr wrap="square" rtlCol="0" anchor="ctr"/>
           <a:lstStyle/>
           <a:p>
-            <a:pPr algn="r" indent="0" marL="0">
+            <a:pPr marL="0" indent="0" algn="r">
               <a:buNone/>
             </a:pPr>
             <a:r>
@@ -7109,7 +6589,7 @@
           <a:bodyPr wrap="square" rtlCol="0" anchor="ctr"/>
           <a:lstStyle/>
           <a:p>
-            <a:pPr indent="0" marL="0">
+            <a:pPr marL="0" indent="0">
               <a:buNone/>
             </a:pPr>
             <a:r>
@@ -7127,22 +6607,6 @@
           </a:p>
         </p:txBody>
       </p:sp>
-      <p:graphicFrame>
-        <p:nvGraphicFramePr>
-          <p:cNvPr id="6" name="Chart 0" descr=""/>
-          <p:cNvGraphicFramePr/>
-          <p:nvPr/>
-        </p:nvGraphicFramePr>
-        <p:xfrm>
-          <a:off x="548640" y="1600200"/>
-          <a:ext cx="6492240" cy="3200400"/>
-        </p:xfrm>
-        <a:graphic xmlns:a="http://schemas.openxmlformats.org/drawingml/2006/main">
-          <a:graphicData uri="http://schemas.openxmlformats.org/drawingml/2006/chart">
-            <c:chart xmlns:c="http://schemas.openxmlformats.org/drawingml/2006/chart" r:id="rId1"/>
-          </a:graphicData>
-        </a:graphic>
-      </p:graphicFrame>
       <p:sp>
         <p:nvSpPr>
           <p:cNvPr id="7" name="Text 4"/>
@@ -7164,7 +6628,7 @@
           <a:bodyPr wrap="square" rtlCol="0" anchor="ctr"/>
           <a:lstStyle/>
           <a:p>
-            <a:pPr indent="0" marL="0">
+            <a:pPr marL="0" indent="0">
               <a:buNone/>
             </a:pPr>
             <a:r>
@@ -7208,6 +6672,13 @@
             <a:prstDash val="solid"/>
           </a:ln>
         </p:spPr>
+        <p:txBody>
+          <a:bodyPr/>
+          <a:lstStyle/>
+          <a:p>
+            <a:endParaRPr lang="en-US"/>
+          </a:p>
+        </p:txBody>
       </p:sp>
       <p:sp>
         <p:nvSpPr>
@@ -7230,7 +6701,7 @@
           <a:bodyPr wrap="square" rtlCol="0" anchor="ctr"/>
           <a:lstStyle/>
           <a:p>
-            <a:pPr indent="0" marL="0">
+            <a:pPr marL="0" indent="0">
               <a:buNone/>
             </a:pPr>
             <a:r>
@@ -7269,7 +6740,7 @@
           <a:bodyPr wrap="square" rtlCol="0" anchor="ctr"/>
           <a:lstStyle/>
           <a:p>
-            <a:pPr indent="0" marL="0">
+            <a:pPr marL="0" indent="0">
               <a:buNone/>
             </a:pPr>
             <a:r>
@@ -7313,6 +6784,13 @@
             <a:prstDash val="solid"/>
           </a:ln>
         </p:spPr>
+        <p:txBody>
+          <a:bodyPr/>
+          <a:lstStyle/>
+          <a:p>
+            <a:endParaRPr lang="en-US"/>
+          </a:p>
+        </p:txBody>
       </p:sp>
       <p:sp>
         <p:nvSpPr>
@@ -7335,7 +6813,7 @@
           <a:bodyPr wrap="square" rtlCol="0" anchor="ctr"/>
           <a:lstStyle/>
           <a:p>
-            <a:pPr algn="ctr" indent="0" marL="0">
+            <a:pPr marL="0" indent="0" algn="ctr">
               <a:buNone/>
             </a:pPr>
             <a:r>
@@ -7374,7 +6852,7 @@
           <a:bodyPr wrap="square" rtlCol="0" anchor="ctr"/>
           <a:lstStyle/>
           <a:p>
-            <a:pPr algn="ctr" indent="0" marL="0">
+            <a:pPr marL="0" indent="0" algn="ctr">
               <a:buNone/>
             </a:pPr>
             <a:r>
@@ -7391,7 +6869,7 @@
             <a:endParaRPr lang="en-US" sz="1100" dirty="0"/>
           </a:p>
           <a:p>
-            <a:pPr algn="ctr" indent="0" marL="0">
+            <a:pPr marL="0" indent="0" algn="ctr">
               <a:buNone/>
             </a:pPr>
             <a:r>
@@ -7435,6 +6913,13 @@
             <a:prstDash val="solid"/>
           </a:ln>
         </p:spPr>
+        <p:txBody>
+          <a:bodyPr/>
+          <a:lstStyle/>
+          <a:p>
+            <a:endParaRPr lang="en-US"/>
+          </a:p>
+        </p:txBody>
       </p:sp>
       <p:sp>
         <p:nvSpPr>
@@ -7457,7 +6942,7 @@
           <a:bodyPr wrap="square" rtlCol="0" anchor="ctr"/>
           <a:lstStyle/>
           <a:p>
-            <a:pPr algn="ctr" indent="0" marL="0">
+            <a:pPr marL="0" indent="0" algn="ctr">
               <a:buNone/>
             </a:pPr>
             <a:r>
@@ -7496,7 +6981,7 @@
           <a:bodyPr wrap="square" rtlCol="0" anchor="ctr"/>
           <a:lstStyle/>
           <a:p>
-            <a:pPr algn="ctr" indent="0" marL="0">
+            <a:pPr marL="0" indent="0" algn="ctr">
               <a:buNone/>
             </a:pPr>
             <a:r>
@@ -7513,7 +6998,7 @@
             <a:endParaRPr lang="en-US" sz="1100" dirty="0"/>
           </a:p>
           <a:p>
-            <a:pPr algn="ctr" indent="0" marL="0">
+            <a:pPr marL="0" indent="0" algn="ctr">
               <a:buNone/>
             </a:pPr>
             <a:r>
@@ -7552,7 +7037,7 @@
           <a:bodyPr wrap="square" rtlCol="0" anchor="ctr"/>
           <a:lstStyle/>
           <a:p>
-            <a:pPr indent="0" marL="0">
+            <a:pPr marL="0" indent="0">
               <a:buNone/>
             </a:pPr>
             <a:r>
@@ -7570,6 +7055,36 @@
           </a:p>
         </p:txBody>
       </p:sp>
+      <p:pic>
+        <p:nvPicPr>
+          <p:cNvPr id="19" name="Picture 18">
+            <a:extLst>
+              <a:ext uri="{FF2B5EF4-FFF2-40B4-BE49-F238E27FC236}">
+                <a16:creationId xmlns:a16="http://schemas.microsoft.com/office/drawing/2014/main" id="{73DB80FF-556B-116C-6C61-B9F8614C1EF2}"/>
+              </a:ext>
+            </a:extLst>
+          </p:cNvPr>
+          <p:cNvPicPr>
+            <a:picLocks noChangeAspect="1"/>
+          </p:cNvPicPr>
+          <p:nvPr/>
+        </p:nvPicPr>
+        <p:blipFill>
+          <a:blip r:embed="rId3"/>
+          <a:stretch>
+            <a:fillRect/>
+          </a:stretch>
+        </p:blipFill>
+        <p:spPr>
+          <a:xfrm>
+            <a:off x="306308" y="1417314"/>
+            <a:ext cx="6734572" cy="3429006"/>
+          </a:xfrm>
+          <a:prstGeom prst="rect">
+            <a:avLst/>
+          </a:prstGeom>
+        </p:spPr>
+      </p:pic>
     </p:spTree>
   </p:cSld>
   <p:clrMapOvr>
@@ -7586,6 +7101,7 @@
         <a:solidFill>
           <a:srgbClr val="FFFFFF"/>
         </a:solidFill>
+        <a:effectLst/>
       </p:bgPr>
     </p:bg>
     <p:spTree>
@@ -7623,7 +7139,7 @@
           <a:bodyPr wrap="square" rtlCol="0" anchor="ctr"/>
           <a:lstStyle/>
           <a:p>
-            <a:pPr indent="0" marL="0">
+            <a:pPr marL="0" indent="0">
               <a:buNone/>
             </a:pPr>
             <a:r>
@@ -7662,7 +7178,7 @@
           <a:bodyPr wrap="square" rtlCol="0" anchor="ctr"/>
           <a:lstStyle/>
           <a:p>
-            <a:pPr indent="0" marL="0">
+            <a:pPr marL="0" indent="0">
               <a:buNone/>
             </a:pPr>
             <a:r>
@@ -7701,7 +7217,7 @@
           <a:bodyPr wrap="square" rtlCol="0" anchor="ctr"/>
           <a:lstStyle/>
           <a:p>
-            <a:pPr algn="r" indent="0" marL="0">
+            <a:pPr marL="0" indent="0" algn="r">
               <a:buNone/>
             </a:pPr>
             <a:r>
@@ -7740,7 +7256,7 @@
           <a:bodyPr wrap="square" rtlCol="0" anchor="ctr"/>
           <a:lstStyle/>
           <a:p>
-            <a:pPr indent="0" marL="0">
+            <a:pPr marL="0" indent="0">
               <a:buNone/>
             </a:pPr>
             <a:r>
@@ -7784,6 +7300,13 @@
             <a:prstDash val="solid"/>
           </a:ln>
         </p:spPr>
+        <p:txBody>
+          <a:bodyPr/>
+          <a:lstStyle/>
+          <a:p>
+            <a:endParaRPr lang="en-US"/>
+          </a:p>
+        </p:txBody>
       </p:sp>
       <p:sp>
         <p:nvSpPr>
@@ -7806,7 +7329,7 @@
           <a:bodyPr wrap="square" rtlCol="0" anchor="ctr"/>
           <a:lstStyle/>
           <a:p>
-            <a:pPr indent="0" marL="0">
+            <a:pPr marL="0" indent="0">
               <a:buNone/>
             </a:pPr>
             <a:r>
@@ -7845,7 +7368,7 @@
           <a:bodyPr wrap="square" rtlCol="0" anchor="ctr"/>
           <a:lstStyle/>
           <a:p>
-            <a:pPr indent="0" marL="0">
+            <a:pPr marL="0" indent="0">
               <a:buNone/>
             </a:pPr>
             <a:r>
@@ -7859,9 +7382,6 @@
               </a:rPr>
               <a:t>In 97.5 percent of frauds the amount equals the account balance </a:t>
             </a:r>
-            <a:pPr indent="0" marL="0">
-              <a:buNone/>
-            </a:pPr>
             <a:r>
               <a:rPr lang="en-US" sz="1300" b="1" dirty="0">
                 <a:solidFill>
@@ -7873,9 +7393,6 @@
               </a:rPr>
               <a:t>to the cent</a:t>
             </a:r>
-            <a:pPr indent="0" marL="0">
-              <a:buNone/>
-            </a:pPr>
             <a:r>
               <a:rPr lang="en-US" sz="1300" dirty="0">
                 <a:solidFill>
@@ -7912,7 +7429,7 @@
           <a:bodyPr wrap="square" rtlCol="0" anchor="ctr"/>
           <a:lstStyle/>
           <a:p>
-            <a:pPr indent="0" marL="0">
+            <a:pPr marL="0" indent="0">
               <a:buNone/>
             </a:pPr>
             <a:r>
@@ -7956,6 +7473,13 @@
             <a:prstDash val="solid"/>
           </a:ln>
         </p:spPr>
+        <p:txBody>
+          <a:bodyPr/>
+          <a:lstStyle/>
+          <a:p>
+            <a:endParaRPr lang="en-US"/>
+          </a:p>
+        </p:txBody>
       </p:sp>
       <p:sp>
         <p:nvSpPr>
@@ -7978,7 +7502,7 @@
           <a:bodyPr wrap="square" rtlCol="0" anchor="ctr"/>
           <a:lstStyle/>
           <a:p>
-            <a:pPr indent="0" marL="0">
+            <a:pPr marL="0" indent="0">
               <a:buNone/>
             </a:pPr>
             <a:r>
@@ -8017,7 +7541,7 @@
           <a:bodyPr wrap="square" rtlCol="0" anchor="ctr"/>
           <a:lstStyle/>
           <a:p>
-            <a:pPr indent="0" marL="0">
+            <a:pPr marL="0" indent="0">
               <a:buNone/>
             </a:pPr>
             <a:r>
@@ -8037,7 +7561,7 @@
       </p:sp>
       <p:graphicFrame>
         <p:nvGraphicFramePr>
-          <p:cNvPr id="13" name="Chart 0" descr=""/>
+          <p:cNvPr id="13" name="Chart 0"/>
           <p:cNvGraphicFramePr/>
           <p:nvPr/>
         </p:nvGraphicFramePr>
@@ -8045,9 +7569,9 @@
           <a:off x="548640" y="3749040"/>
           <a:ext cx="10972800" cy="1737360"/>
         </p:xfrm>
-        <a:graphic xmlns:a="http://schemas.openxmlformats.org/drawingml/2006/main">
+        <a:graphic>
           <a:graphicData uri="http://schemas.openxmlformats.org/drawingml/2006/chart">
-            <c:chart xmlns:c="http://schemas.openxmlformats.org/drawingml/2006/chart" r:id="rId1"/>
+            <c:chart xmlns:c="http://schemas.openxmlformats.org/drawingml/2006/chart" xmlns:r="http://schemas.openxmlformats.org/officeDocument/2006/relationships" r:id="rId3"/>
           </a:graphicData>
         </a:graphic>
       </p:graphicFrame>
@@ -8067,6 +7591,7 @@
         <a:solidFill>
           <a:srgbClr val="FFFFFF"/>
         </a:solidFill>
+        <a:effectLst/>
       </p:bgPr>
     </p:bg>
     <p:spTree>
@@ -8104,7 +7629,7 @@
           <a:bodyPr wrap="square" rtlCol="0" anchor="ctr"/>
           <a:lstStyle/>
           <a:p>
-            <a:pPr indent="0" marL="0">
+            <a:pPr marL="0" indent="0">
               <a:buNone/>
             </a:pPr>
             <a:r>
@@ -8143,7 +7668,7 @@
           <a:bodyPr wrap="square" rtlCol="0" anchor="ctr"/>
           <a:lstStyle/>
           <a:p>
-            <a:pPr indent="0" marL="0">
+            <a:pPr marL="0" indent="0">
               <a:buNone/>
             </a:pPr>
             <a:r>
@@ -8182,7 +7707,7 @@
           <a:bodyPr wrap="square" rtlCol="0" anchor="ctr"/>
           <a:lstStyle/>
           <a:p>
-            <a:pPr algn="r" indent="0" marL="0">
+            <a:pPr marL="0" indent="0" algn="r">
               <a:buNone/>
             </a:pPr>
             <a:r>
@@ -8221,7 +7746,7 @@
           <a:bodyPr wrap="square" rtlCol="0" anchor="ctr"/>
           <a:lstStyle/>
           <a:p>
-            <a:pPr indent="0" marL="0">
+            <a:pPr marL="0" indent="0">
               <a:buNone/>
             </a:pPr>
             <a:r>
@@ -8265,6 +7790,13 @@
             <a:prstDash val="solid"/>
           </a:ln>
         </p:spPr>
+        <p:txBody>
+          <a:bodyPr/>
+          <a:lstStyle/>
+          <a:p>
+            <a:endParaRPr lang="en-US"/>
+          </a:p>
+        </p:txBody>
       </p:sp>
       <p:sp>
         <p:nvSpPr>
@@ -8287,7 +7819,7 @@
           <a:bodyPr wrap="square" rtlCol="0" anchor="ctr"/>
           <a:lstStyle/>
           <a:p>
-            <a:pPr indent="0" marL="0">
+            <a:pPr marL="0" indent="0">
               <a:buNone/>
             </a:pPr>
             <a:r>
@@ -8326,7 +7858,7 @@
           <a:bodyPr wrap="square" rtlCol="0" anchor="ctr"/>
           <a:lstStyle/>
           <a:p>
-            <a:pPr indent="0" marL="0">
+            <a:pPr marL="0" indent="0">
               <a:buNone/>
             </a:pPr>
             <a:r>
@@ -8370,6 +7902,13 @@
             <a:prstDash val="solid"/>
           </a:ln>
         </p:spPr>
+        <p:txBody>
+          <a:bodyPr/>
+          <a:lstStyle/>
+          <a:p>
+            <a:endParaRPr lang="en-US"/>
+          </a:p>
+        </p:txBody>
       </p:sp>
       <p:sp>
         <p:nvSpPr>
@@ -8392,7 +7931,7 @@
           <a:bodyPr wrap="square" rtlCol="0" anchor="ctr"/>
           <a:lstStyle/>
           <a:p>
-            <a:pPr indent="0" marL="0">
+            <a:pPr marL="0" indent="0">
               <a:buNone/>
             </a:pPr>
             <a:r>
@@ -8431,7 +7970,7 @@
           <a:bodyPr wrap="square" rtlCol="0" anchor="ctr"/>
           <a:lstStyle/>
           <a:p>
-            <a:pPr indent="0" marL="0">
+            <a:pPr marL="0" indent="0">
               <a:buNone/>
             </a:pPr>
             <a:r>
@@ -8475,6 +8014,13 @@
             <a:prstDash val="solid"/>
           </a:ln>
         </p:spPr>
+        <p:txBody>
+          <a:bodyPr/>
+          <a:lstStyle/>
+          <a:p>
+            <a:endParaRPr lang="en-US"/>
+          </a:p>
+        </p:txBody>
       </p:sp>
       <p:sp>
         <p:nvSpPr>
@@ -8497,7 +8043,7 @@
           <a:bodyPr wrap="square" rtlCol="0" anchor="ctr"/>
           <a:lstStyle/>
           <a:p>
-            <a:pPr indent="0" marL="0">
+            <a:pPr marL="0" indent="0">
               <a:buNone/>
             </a:pPr>
             <a:r>
@@ -8536,7 +8082,7 @@
           <a:bodyPr wrap="square" rtlCol="0" anchor="ctr"/>
           <a:lstStyle/>
           <a:p>
-            <a:pPr indent="0" marL="0">
+            <a:pPr marL="0" indent="0">
               <a:buNone/>
             </a:pPr>
             <a:r>
@@ -8580,6 +8126,13 @@
             <a:prstDash val="solid"/>
           </a:ln>
         </p:spPr>
+        <p:txBody>
+          <a:bodyPr/>
+          <a:lstStyle/>
+          <a:p>
+            <a:endParaRPr lang="en-US"/>
+          </a:p>
+        </p:txBody>
       </p:sp>
       <p:sp>
         <p:nvSpPr>
@@ -8602,7 +8155,7 @@
           <a:bodyPr wrap="square" rtlCol="0" anchor="ctr"/>
           <a:lstStyle/>
           <a:p>
-            <a:pPr indent="0" marL="0">
+            <a:pPr marL="0" indent="0">
               <a:buNone/>
             </a:pPr>
             <a:r>
@@ -8641,7 +8194,7 @@
           <a:bodyPr wrap="square" rtlCol="0" anchor="ctr"/>
           <a:lstStyle/>
           <a:p>
-            <a:pPr indent="0" marL="0">
+            <a:pPr marL="0" indent="0">
               <a:buNone/>
             </a:pPr>
             <a:r>
@@ -8685,6 +8238,13 @@
             <a:prstDash val="solid"/>
           </a:ln>
         </p:spPr>
+        <p:txBody>
+          <a:bodyPr/>
+          <a:lstStyle/>
+          <a:p>
+            <a:endParaRPr lang="en-US"/>
+          </a:p>
+        </p:txBody>
       </p:sp>
       <p:sp>
         <p:nvSpPr>
@@ -8707,7 +8267,7 @@
           <a:bodyPr wrap="square" rtlCol="0" anchor="ctr"/>
           <a:lstStyle/>
           <a:p>
-            <a:pPr indent="0" marL="0">
+            <a:pPr marL="0" indent="0">
               <a:buNone/>
             </a:pPr>
             <a:r>
@@ -8746,7 +8306,7 @@
           <a:bodyPr wrap="square" rtlCol="0" anchor="ctr"/>
           <a:lstStyle/>
           <a:p>
-            <a:pPr indent="0" marL="0">
+            <a:pPr marL="0" indent="0">
               <a:lnSpc>
                 <a:spcPts val="2500"/>
               </a:lnSpc>
@@ -8763,12 +8323,6 @@
               </a:rPr>
               <a:t>A   Basic</a:t>
             </a:r>
-            <a:pPr indent="0" marL="0">
-              <a:lnSpc>
-                <a:spcPts val="2500"/>
-              </a:lnSpc>
-              <a:buNone/>
-            </a:pPr>
             <a:r>
               <a:rPr lang="en-US" sz="1250" dirty="0">
                 <a:solidFill>
@@ -8781,12 +8335,6 @@
               <a:t>   amount, cycle position, type
 </a:t>
             </a:r>
-            <a:pPr indent="0" marL="0">
-              <a:lnSpc>
-                <a:spcPts val="2500"/>
-              </a:lnSpc>
-              <a:buNone/>
-            </a:pPr>
             <a:r>
               <a:rPr lang="en-US" sz="1250" b="1" dirty="0">
                 <a:solidFill>
@@ -8798,12 +8346,6 @@
               </a:rPr>
               <a:t>B   With balances</a:t>
             </a:r>
-            <a:pPr indent="0" marL="0">
-              <a:lnSpc>
-                <a:spcPts val="2500"/>
-              </a:lnSpc>
-              <a:buNone/>
-            </a:pPr>
             <a:r>
               <a:rPr lang="en-US" sz="1250" dirty="0">
                 <a:solidFill>
@@ -8816,12 +8358,6 @@
               <a:t>   plus pre transaction balances
 </a:t>
             </a:r>
-            <a:pPr indent="0" marL="0">
-              <a:lnSpc>
-                <a:spcPts val="2500"/>
-              </a:lnSpc>
-              <a:buNone/>
-            </a:pPr>
             <a:r>
               <a:rPr lang="en-US" sz="1250" b="1" dirty="0">
                 <a:solidFill>
@@ -8833,12 +8369,6 @@
               </a:rPr>
               <a:t>C   Balance errors</a:t>
             </a:r>
-            <a:pPr indent="0" marL="0">
-              <a:lnSpc>
-                <a:spcPts val="2500"/>
-              </a:lnSpc>
-              <a:buNone/>
-            </a:pPr>
             <a:r>
               <a:rPr lang="en-US" sz="1250" dirty="0">
                 <a:solidFill>
@@ -8880,6 +8410,13 @@
             <a:prstDash val="solid"/>
           </a:ln>
         </p:spPr>
+        <p:txBody>
+          <a:bodyPr/>
+          <a:lstStyle/>
+          <a:p>
+            <a:endParaRPr lang="en-US"/>
+          </a:p>
+        </p:txBody>
       </p:sp>
       <p:sp>
         <p:nvSpPr>
@@ -8902,7 +8439,7 @@
           <a:bodyPr wrap="square" rtlCol="0" anchor="ctr"/>
           <a:lstStyle/>
           <a:p>
-            <a:pPr indent="0" marL="0">
+            <a:pPr marL="0" indent="0">
               <a:buNone/>
             </a:pPr>
             <a:r>
@@ -8941,7 +8478,7 @@
           <a:bodyPr wrap="square" rtlCol="0" anchor="ctr"/>
           <a:lstStyle/>
           <a:p>
-            <a:pPr indent="0" marL="0">
+            <a:pPr marL="0" indent="0">
               <a:buNone/>
             </a:pPr>
             <a:r>
@@ -8975,6 +8512,7 @@
         <a:solidFill>
           <a:srgbClr val="FFFFFF"/>
         </a:solidFill>
+        <a:effectLst/>
       </p:bgPr>
     </p:bg>
     <p:spTree>
@@ -9012,7 +8550,7 @@
           <a:bodyPr wrap="square" rtlCol="0" anchor="ctr"/>
           <a:lstStyle/>
           <a:p>
-            <a:pPr indent="0" marL="0">
+            <a:pPr marL="0" indent="0">
               <a:buNone/>
             </a:pPr>
             <a:r>
@@ -9051,7 +8589,7 @@
           <a:bodyPr wrap="square" rtlCol="0" anchor="ctr"/>
           <a:lstStyle/>
           <a:p>
-            <a:pPr indent="0" marL="0">
+            <a:pPr marL="0" indent="0">
               <a:buNone/>
             </a:pPr>
             <a:r>
@@ -9090,7 +8628,7 @@
           <a:bodyPr wrap="square" rtlCol="0" anchor="ctr"/>
           <a:lstStyle/>
           <a:p>
-            <a:pPr algn="r" indent="0" marL="0">
+            <a:pPr marL="0" indent="0" algn="r">
               <a:buNone/>
             </a:pPr>
             <a:r>
@@ -9129,7 +8667,7 @@
           <a:bodyPr wrap="square" rtlCol="0" anchor="ctr"/>
           <a:lstStyle/>
           <a:p>
-            <a:pPr indent="0" marL="0">
+            <a:pPr marL="0" indent="0">
               <a:buNone/>
             </a:pPr>
             <a:r>
@@ -9170,10 +8708,34 @@
             <a:tbl>
               <a:tblPr/>
               <a:tblGrid>
-                <a:gridCol w="4114800"/>
-                <a:gridCol w="2286000"/>
-                <a:gridCol w="2286000"/>
-                <a:gridCol w="2286000"/>
+                <a:gridCol w="4114800">
+                  <a:extLst>
+                    <a:ext uri="{9D8B030D-6E8A-4147-A177-3AD203B41FA5}">
+                      <a16:colId xmlns:a16="http://schemas.microsoft.com/office/drawing/2014/main" val="20000"/>
+                    </a:ext>
+                  </a:extLst>
+                </a:gridCol>
+                <a:gridCol w="2286000">
+                  <a:extLst>
+                    <a:ext uri="{9D8B030D-6E8A-4147-A177-3AD203B41FA5}">
+                      <a16:colId xmlns:a16="http://schemas.microsoft.com/office/drawing/2014/main" val="20001"/>
+                    </a:ext>
+                  </a:extLst>
+                </a:gridCol>
+                <a:gridCol w="2286000">
+                  <a:extLst>
+                    <a:ext uri="{9D8B030D-6E8A-4147-A177-3AD203B41FA5}">
+                      <a16:colId xmlns:a16="http://schemas.microsoft.com/office/drawing/2014/main" val="20002"/>
+                    </a:ext>
+                  </a:extLst>
+                </a:gridCol>
+                <a:gridCol w="2286000">
+                  <a:extLst>
+                    <a:ext uri="{9D8B030D-6E8A-4147-A177-3AD203B41FA5}">
+                      <a16:colId xmlns:a16="http://schemas.microsoft.com/office/drawing/2014/main" val="20003"/>
+                    </a:ext>
+                  </a:extLst>
+                </a:gridCol>
               </a:tblGrid>
               <a:tr h="475488">
                 <a:tc>
@@ -9181,7 +8743,7 @@
                     <a:bodyPr/>
                     <a:lstStyle/>
                     <a:p>
-                      <a:pPr algn="ctr" indent="0" marL="0">
+                      <a:pPr marL="0" indent="0" algn="ctr">
                         <a:buNone/>
                       </a:pPr>
                       <a:r>
@@ -9202,7 +8764,7 @@
                       </a:endParaRPr>
                     </a:p>
                   </a:txBody>
-                  <a:tcPr marL="91440" marR="91440" marT="45720" marB="45720" anchor="ctr">
+                  <a:tcPr anchor="ctr">
                     <a:lnL w="12700" cap="flat" cmpd="sng" algn="ctr">
                       <a:solidFill>
                         <a:srgbClr val="D5DEEF"/>
@@ -9249,7 +8811,7 @@
                     <a:bodyPr/>
                     <a:lstStyle/>
                     <a:p>
-                      <a:pPr algn="ctr" indent="0" marL="0">
+                      <a:pPr marL="0" indent="0" algn="ctr">
                         <a:buNone/>
                       </a:pPr>
                       <a:r>
@@ -9270,7 +8832,7 @@
                       </a:endParaRPr>
                     </a:p>
                   </a:txBody>
-                  <a:tcPr marL="91440" marR="91440" marT="45720" marB="45720" anchor="ctr">
+                  <a:tcPr anchor="ctr">
                     <a:lnL w="12700" cap="flat" cmpd="sng" algn="ctr">
                       <a:solidFill>
                         <a:srgbClr val="D5DEEF"/>
@@ -9317,7 +8879,7 @@
                     <a:bodyPr/>
                     <a:lstStyle/>
                     <a:p>
-                      <a:pPr algn="ctr" indent="0" marL="0">
+                      <a:pPr marL="0" indent="0" algn="ctr">
                         <a:buNone/>
                       </a:pPr>
                       <a:r>
@@ -9338,7 +8900,7 @@
                       </a:endParaRPr>
                     </a:p>
                   </a:txBody>
-                  <a:tcPr marL="91440" marR="91440" marT="45720" marB="45720" anchor="ctr">
+                  <a:tcPr anchor="ctr">
                     <a:lnL w="12700" cap="flat" cmpd="sng" algn="ctr">
                       <a:solidFill>
                         <a:srgbClr val="D5DEEF"/>
@@ -9385,7 +8947,7 @@
                     <a:bodyPr/>
                     <a:lstStyle/>
                     <a:p>
-                      <a:pPr algn="ctr" indent="0" marL="0">
+                      <a:pPr marL="0" indent="0" algn="ctr">
                         <a:buNone/>
                       </a:pPr>
                       <a:r>
@@ -9406,7 +8968,7 @@
                       </a:endParaRPr>
                     </a:p>
                   </a:txBody>
-                  <a:tcPr marL="91440" marR="91440" marT="45720" marB="45720" anchor="ctr">
+                  <a:tcPr anchor="ctr">
                     <a:lnL w="12700" cap="flat" cmpd="sng" algn="ctr">
                       <a:solidFill>
                         <a:srgbClr val="D5DEEF"/>
@@ -9448,6 +9010,11 @@
                     </a:solidFill>
                   </a:tcPr>
                 </a:tc>
+                <a:extLst>
+                  <a:ext uri="{0D108BD9-81ED-4DB2-BD59-A6C34878D82A}">
+                    <a16:rowId xmlns:a16="http://schemas.microsoft.com/office/drawing/2014/main" val="10000"/>
+                  </a:ext>
+                </a:extLst>
               </a:tr>
               <a:tr h="475488">
                 <a:tc>
@@ -9455,7 +9022,7 @@
                     <a:bodyPr/>
                     <a:lstStyle/>
                     <a:p>
-                      <a:pPr algn="ctr" indent="0" marL="0">
+                      <a:pPr marL="0" indent="0" algn="ctr">
                         <a:buNone/>
                       </a:pPr>
                       <a:r>
@@ -9476,7 +9043,7 @@
                       </a:endParaRPr>
                     </a:p>
                   </a:txBody>
-                  <a:tcPr marL="91440" marR="91440" marT="45720" marB="45720" anchor="ctr">
+                  <a:tcPr anchor="ctr">
                     <a:lnL w="12700" cap="flat" cmpd="sng" algn="ctr">
                       <a:solidFill>
                         <a:srgbClr val="D5DEEF"/>
@@ -9523,7 +9090,7 @@
                     <a:bodyPr/>
                     <a:lstStyle/>
                     <a:p>
-                      <a:pPr algn="ctr" indent="0" marL="0">
+                      <a:pPr marL="0" indent="0" algn="ctr">
                         <a:buNone/>
                       </a:pPr>
                       <a:r>
@@ -9544,7 +9111,7 @@
                       </a:endParaRPr>
                     </a:p>
                   </a:txBody>
-                  <a:tcPr marL="91440" marR="91440" marT="45720" marB="45720" anchor="ctr">
+                  <a:tcPr anchor="ctr">
                     <a:lnL w="12700" cap="flat" cmpd="sng" algn="ctr">
                       <a:solidFill>
                         <a:srgbClr val="D5DEEF"/>
@@ -9591,7 +9158,7 @@
                     <a:bodyPr/>
                     <a:lstStyle/>
                     <a:p>
-                      <a:pPr algn="ctr" indent="0" marL="0">
+                      <a:pPr marL="0" indent="0" algn="ctr">
                         <a:buNone/>
                       </a:pPr>
                       <a:r>
@@ -9612,7 +9179,7 @@
                       </a:endParaRPr>
                     </a:p>
                   </a:txBody>
-                  <a:tcPr marL="91440" marR="91440" marT="45720" marB="45720" anchor="ctr">
+                  <a:tcPr anchor="ctr">
                     <a:lnL w="12700" cap="flat" cmpd="sng" algn="ctr">
                       <a:solidFill>
                         <a:srgbClr val="D5DEEF"/>
@@ -9659,7 +9226,7 @@
                     <a:bodyPr/>
                     <a:lstStyle/>
                     <a:p>
-                      <a:pPr algn="ctr" indent="0" marL="0">
+                      <a:pPr marL="0" indent="0" algn="ctr">
                         <a:buNone/>
                       </a:pPr>
                       <a:r>
@@ -9680,7 +9247,7 @@
                       </a:endParaRPr>
                     </a:p>
                   </a:txBody>
-                  <a:tcPr marL="91440" marR="91440" marT="45720" marB="45720" anchor="ctr">
+                  <a:tcPr anchor="ctr">
                     <a:lnL w="12700" cap="flat" cmpd="sng" algn="ctr">
                       <a:solidFill>
                         <a:srgbClr val="D5DEEF"/>
@@ -9722,6 +9289,11 @@
                     </a:solidFill>
                   </a:tcPr>
                 </a:tc>
+                <a:extLst>
+                  <a:ext uri="{0D108BD9-81ED-4DB2-BD59-A6C34878D82A}">
+                    <a16:rowId xmlns:a16="http://schemas.microsoft.com/office/drawing/2014/main" val="10001"/>
+                  </a:ext>
+                </a:extLst>
               </a:tr>
               <a:tr h="475488">
                 <a:tc>
@@ -9729,7 +9301,7 @@
                     <a:bodyPr/>
                     <a:lstStyle/>
                     <a:p>
-                      <a:pPr algn="ctr" indent="0" marL="0">
+                      <a:pPr marL="0" indent="0" algn="ctr">
                         <a:buNone/>
                       </a:pPr>
                       <a:r>
@@ -9750,7 +9322,7 @@
                       </a:endParaRPr>
                     </a:p>
                   </a:txBody>
-                  <a:tcPr marL="91440" marR="91440" marT="45720" marB="45720" anchor="ctr">
+                  <a:tcPr anchor="ctr">
                     <a:lnL w="12700" cap="flat" cmpd="sng" algn="ctr">
                       <a:solidFill>
                         <a:srgbClr val="D5DEEF"/>
@@ -9797,7 +9369,7 @@
                     <a:bodyPr/>
                     <a:lstStyle/>
                     <a:p>
-                      <a:pPr algn="ctr" indent="0" marL="0">
+                      <a:pPr marL="0" indent="0" algn="ctr">
                         <a:buNone/>
                       </a:pPr>
                       <a:r>
@@ -9818,7 +9390,7 @@
                       </a:endParaRPr>
                     </a:p>
                   </a:txBody>
-                  <a:tcPr marL="91440" marR="91440" marT="45720" marB="45720" anchor="ctr">
+                  <a:tcPr anchor="ctr">
                     <a:lnL w="12700" cap="flat" cmpd="sng" algn="ctr">
                       <a:solidFill>
                         <a:srgbClr val="D5DEEF"/>
@@ -9865,7 +9437,7 @@
                     <a:bodyPr/>
                     <a:lstStyle/>
                     <a:p>
-                      <a:pPr algn="ctr" indent="0" marL="0">
+                      <a:pPr marL="0" indent="0" algn="ctr">
                         <a:buNone/>
                       </a:pPr>
                       <a:r>
@@ -9886,7 +9458,7 @@
                       </a:endParaRPr>
                     </a:p>
                   </a:txBody>
-                  <a:tcPr marL="91440" marR="91440" marT="45720" marB="45720" anchor="ctr">
+                  <a:tcPr anchor="ctr">
                     <a:lnL w="12700" cap="flat" cmpd="sng" algn="ctr">
                       <a:solidFill>
                         <a:srgbClr val="D5DEEF"/>
@@ -9933,7 +9505,7 @@
                     <a:bodyPr/>
                     <a:lstStyle/>
                     <a:p>
-                      <a:pPr algn="ctr" indent="0" marL="0">
+                      <a:pPr marL="0" indent="0" algn="ctr">
                         <a:buNone/>
                       </a:pPr>
                       <a:r>
@@ -9954,7 +9526,7 @@
                       </a:endParaRPr>
                     </a:p>
                   </a:txBody>
-                  <a:tcPr marL="91440" marR="91440" marT="45720" marB="45720" anchor="ctr">
+                  <a:tcPr anchor="ctr">
                     <a:lnL w="12700" cap="flat" cmpd="sng" algn="ctr">
                       <a:solidFill>
                         <a:srgbClr val="D5DEEF"/>
@@ -9996,6 +9568,11 @@
                     </a:solidFill>
                   </a:tcPr>
                 </a:tc>
+                <a:extLst>
+                  <a:ext uri="{0D108BD9-81ED-4DB2-BD59-A6C34878D82A}">
+                    <a16:rowId xmlns:a16="http://schemas.microsoft.com/office/drawing/2014/main" val="10002"/>
+                  </a:ext>
+                </a:extLst>
               </a:tr>
               <a:tr h="475488">
                 <a:tc>
@@ -10003,7 +9580,7 @@
                     <a:bodyPr/>
                     <a:lstStyle/>
                     <a:p>
-                      <a:pPr algn="ctr" indent="0" marL="0">
+                      <a:pPr marL="0" indent="0" algn="ctr">
                         <a:buNone/>
                       </a:pPr>
                       <a:r>
@@ -10024,7 +9601,7 @@
                       </a:endParaRPr>
                     </a:p>
                   </a:txBody>
-                  <a:tcPr marL="91440" marR="91440" marT="45720" marB="45720" anchor="ctr">
+                  <a:tcPr anchor="ctr">
                     <a:lnL w="12700" cap="flat" cmpd="sng" algn="ctr">
                       <a:solidFill>
                         <a:srgbClr val="D5DEEF"/>
@@ -10071,7 +9648,7 @@
                     <a:bodyPr/>
                     <a:lstStyle/>
                     <a:p>
-                      <a:pPr algn="ctr" indent="0" marL="0">
+                      <a:pPr marL="0" indent="0" algn="ctr">
                         <a:buNone/>
                       </a:pPr>
                       <a:r>
@@ -10092,7 +9669,7 @@
                       </a:endParaRPr>
                     </a:p>
                   </a:txBody>
-                  <a:tcPr marL="91440" marR="91440" marT="45720" marB="45720" anchor="ctr">
+                  <a:tcPr anchor="ctr">
                     <a:lnL w="12700" cap="flat" cmpd="sng" algn="ctr">
                       <a:solidFill>
                         <a:srgbClr val="D5DEEF"/>
@@ -10139,7 +9716,7 @@
                     <a:bodyPr/>
                     <a:lstStyle/>
                     <a:p>
-                      <a:pPr algn="ctr" indent="0" marL="0">
+                      <a:pPr marL="0" indent="0" algn="ctr">
                         <a:buNone/>
                       </a:pPr>
                       <a:r>
@@ -10160,7 +9737,7 @@
                       </a:endParaRPr>
                     </a:p>
                   </a:txBody>
-                  <a:tcPr marL="91440" marR="91440" marT="45720" marB="45720" anchor="ctr">
+                  <a:tcPr anchor="ctr">
                     <a:lnL w="12700" cap="flat" cmpd="sng" algn="ctr">
                       <a:solidFill>
                         <a:srgbClr val="D5DEEF"/>
@@ -10207,7 +9784,7 @@
                     <a:bodyPr/>
                     <a:lstStyle/>
                     <a:p>
-                      <a:pPr algn="ctr" indent="0" marL="0">
+                      <a:pPr marL="0" indent="0" algn="ctr">
                         <a:buNone/>
                       </a:pPr>
                       <a:r>
@@ -10228,7 +9805,7 @@
                       </a:endParaRPr>
                     </a:p>
                   </a:txBody>
-                  <a:tcPr marL="91440" marR="91440" marT="45720" marB="45720" anchor="ctr">
+                  <a:tcPr anchor="ctr">
                     <a:lnL w="12700" cap="flat" cmpd="sng" algn="ctr">
                       <a:solidFill>
                         <a:srgbClr val="D5DEEF"/>
@@ -10270,6 +9847,11 @@
                     </a:solidFill>
                   </a:tcPr>
                 </a:tc>
+                <a:extLst>
+                  <a:ext uri="{0D108BD9-81ED-4DB2-BD59-A6C34878D82A}">
+                    <a16:rowId xmlns:a16="http://schemas.microsoft.com/office/drawing/2014/main" val="10003"/>
+                  </a:ext>
+                </a:extLst>
               </a:tr>
               <a:tr h="475488">
                 <a:tc>
@@ -10277,7 +9859,7 @@
                     <a:bodyPr/>
                     <a:lstStyle/>
                     <a:p>
-                      <a:pPr algn="ctr" indent="0" marL="0">
+                      <a:pPr marL="0" indent="0" algn="ctr">
                         <a:buNone/>
                       </a:pPr>
                       <a:r>
@@ -10298,7 +9880,7 @@
                       </a:endParaRPr>
                     </a:p>
                   </a:txBody>
-                  <a:tcPr marL="91440" marR="91440" marT="45720" marB="45720" anchor="ctr">
+                  <a:tcPr anchor="ctr">
                     <a:lnL w="12700" cap="flat" cmpd="sng" algn="ctr">
                       <a:solidFill>
                         <a:srgbClr val="D5DEEF"/>
@@ -10345,7 +9927,7 @@
                     <a:bodyPr/>
                     <a:lstStyle/>
                     <a:p>
-                      <a:pPr algn="ctr" indent="0" marL="0">
+                      <a:pPr marL="0" indent="0" algn="ctr">
                         <a:buNone/>
                       </a:pPr>
                       <a:r>
@@ -10366,7 +9948,7 @@
                       </a:endParaRPr>
                     </a:p>
                   </a:txBody>
-                  <a:tcPr marL="91440" marR="91440" marT="45720" marB="45720" anchor="ctr">
+                  <a:tcPr anchor="ctr">
                     <a:lnL w="12700" cap="flat" cmpd="sng" algn="ctr">
                       <a:solidFill>
                         <a:srgbClr val="D5DEEF"/>
@@ -10413,7 +9995,7 @@
                     <a:bodyPr/>
                     <a:lstStyle/>
                     <a:p>
-                      <a:pPr algn="ctr" indent="0" marL="0">
+                      <a:pPr marL="0" indent="0" algn="ctr">
                         <a:buNone/>
                       </a:pPr>
                       <a:r>
@@ -10434,7 +10016,7 @@
                       </a:endParaRPr>
                     </a:p>
                   </a:txBody>
-                  <a:tcPr marL="91440" marR="91440" marT="45720" marB="45720" anchor="ctr">
+                  <a:tcPr anchor="ctr">
                     <a:lnL w="12700" cap="flat" cmpd="sng" algn="ctr">
                       <a:solidFill>
                         <a:srgbClr val="D5DEEF"/>
@@ -10481,7 +10063,7 @@
                     <a:bodyPr/>
                     <a:lstStyle/>
                     <a:p>
-                      <a:pPr algn="ctr" indent="0" marL="0">
+                      <a:pPr marL="0" indent="0" algn="ctr">
                         <a:buNone/>
                       </a:pPr>
                       <a:r>
@@ -10502,7 +10084,7 @@
                       </a:endParaRPr>
                     </a:p>
                   </a:txBody>
-                  <a:tcPr marL="91440" marR="91440" marT="45720" marB="45720" anchor="ctr">
+                  <a:tcPr anchor="ctr">
                     <a:lnL w="12700" cap="flat" cmpd="sng" algn="ctr">
                       <a:solidFill>
                         <a:srgbClr val="D5DEEF"/>
@@ -10544,6 +10126,11 @@
                     </a:solidFill>
                   </a:tcPr>
                 </a:tc>
+                <a:extLst>
+                  <a:ext uri="{0D108BD9-81ED-4DB2-BD59-A6C34878D82A}">
+                    <a16:rowId xmlns:a16="http://schemas.microsoft.com/office/drawing/2014/main" val="10004"/>
+                  </a:ext>
+                </a:extLst>
               </a:tr>
             </a:tbl>
           </a:graphicData>
@@ -10575,10 +10162,17 @@
             <a:prstDash val="solid"/>
           </a:ln>
         </p:spPr>
-      </p:sp>
-      <p:sp>
-        <p:nvSpPr>
-          <p:cNvPr id="8" name="Text 5"/>
+        <p:txBody>
+          <a:bodyPr/>
+          <a:lstStyle/>
+          <a:p>
+            <a:endParaRPr lang="en-US"/>
+          </a:p>
+        </p:txBody>
+      </p:sp>
+      <p:sp>
+        <p:nvSpPr>
+          <p:cNvPr id="6" name="Text 5"/>
           <p:cNvSpPr/>
           <p:nvPr/>
         </p:nvSpPr>
@@ -10597,7 +10191,7 @@
           <a:bodyPr wrap="square" rtlCol="0" anchor="ctr"/>
           <a:lstStyle/>
           <a:p>
-            <a:pPr indent="0" marL="0">
+            <a:pPr marL="0" indent="0">
               <a:buNone/>
             </a:pPr>
             <a:r>
@@ -10636,7 +10230,7 @@
           <a:bodyPr wrap="square" rtlCol="0" anchor="ctr"/>
           <a:lstStyle/>
           <a:p>
-            <a:pPr indent="0" marL="0">
+            <a:pPr marL="0" indent="0">
               <a:buNone/>
             </a:pPr>
             <a:r>
@@ -10680,6 +10274,13 @@
             <a:prstDash val="solid"/>
           </a:ln>
         </p:spPr>
+        <p:txBody>
+          <a:bodyPr/>
+          <a:lstStyle/>
+          <a:p>
+            <a:endParaRPr lang="en-US"/>
+          </a:p>
+        </p:txBody>
       </p:sp>
       <p:sp>
         <p:nvSpPr>
@@ -10702,7 +10303,7 @@
           <a:bodyPr wrap="square" rtlCol="0" anchor="ctr"/>
           <a:lstStyle/>
           <a:p>
-            <a:pPr indent="0" marL="0">
+            <a:pPr marL="0" indent="0">
               <a:buNone/>
             </a:pPr>
             <a:r>
@@ -10741,7 +10342,7 @@
           <a:bodyPr wrap="square" rtlCol="0" anchor="ctr"/>
           <a:lstStyle/>
           <a:p>
-            <a:pPr indent="0" marL="0">
+            <a:pPr marL="0" indent="0">
               <a:buNone/>
             </a:pPr>
             <a:r>
@@ -10785,6 +10386,13 @@
             <a:prstDash val="solid"/>
           </a:ln>
         </p:spPr>
+        <p:txBody>
+          <a:bodyPr/>
+          <a:lstStyle/>
+          <a:p>
+            <a:endParaRPr lang="en-US"/>
+          </a:p>
+        </p:txBody>
       </p:sp>
       <p:sp>
         <p:nvSpPr>
@@ -10807,7 +10415,7 @@
           <a:bodyPr wrap="square" rtlCol="0" anchor="ctr"/>
           <a:lstStyle/>
           <a:p>
-            <a:pPr indent="0" marL="0">
+            <a:pPr marL="0" indent="0">
               <a:buNone/>
             </a:pPr>
             <a:r>
@@ -10846,7 +10454,7 @@
           <a:bodyPr wrap="square" rtlCol="0" anchor="ctr"/>
           <a:lstStyle/>
           <a:p>
-            <a:pPr indent="0" marL="0">
+            <a:pPr marL="0" indent="0">
               <a:buNone/>
             </a:pPr>
             <a:r>
@@ -10880,6 +10488,7 @@
         <a:solidFill>
           <a:srgbClr val="FFFFFF"/>
         </a:solidFill>
+        <a:effectLst/>
       </p:bgPr>
     </p:bg>
     <p:spTree>
@@ -10917,7 +10526,7 @@
           <a:bodyPr wrap="square" rtlCol="0" anchor="ctr"/>
           <a:lstStyle/>
           <a:p>
-            <a:pPr indent="0" marL="0">
+            <a:pPr marL="0" indent="0">
               <a:buNone/>
             </a:pPr>
             <a:r>
@@ -10956,7 +10565,7 @@
           <a:bodyPr wrap="square" rtlCol="0" anchor="ctr"/>
           <a:lstStyle/>
           <a:p>
-            <a:pPr indent="0" marL="0">
+            <a:pPr marL="0" indent="0">
               <a:buNone/>
             </a:pPr>
             <a:r>
@@ -10995,7 +10604,7 @@
           <a:bodyPr wrap="square" rtlCol="0" anchor="ctr"/>
           <a:lstStyle/>
           <a:p>
-            <a:pPr algn="r" indent="0" marL="0">
+            <a:pPr marL="0" indent="0" algn="r">
               <a:buNone/>
             </a:pPr>
             <a:r>
@@ -11034,7 +10643,7 @@
           <a:bodyPr wrap="square" rtlCol="0" anchor="ctr"/>
           <a:lstStyle/>
           <a:p>
-            <a:pPr indent="0" marL="0">
+            <a:pPr marL="0" indent="0">
               <a:buNone/>
             </a:pPr>
             <a:r>
@@ -11078,6 +10687,13 @@
             <a:prstDash val="solid"/>
           </a:ln>
         </p:spPr>
+        <p:txBody>
+          <a:bodyPr/>
+          <a:lstStyle/>
+          <a:p>
+            <a:endParaRPr lang="en-US"/>
+          </a:p>
+        </p:txBody>
       </p:sp>
       <p:sp>
         <p:nvSpPr>
@@ -11100,7 +10716,7 @@
           <a:bodyPr wrap="square" rtlCol="0" anchor="ctr"/>
           <a:lstStyle/>
           <a:p>
-            <a:pPr algn="ctr" indent="0" marL="0">
+            <a:pPr marL="0" indent="0" algn="ctr">
               <a:buNone/>
             </a:pPr>
             <a:r>
@@ -11139,7 +10755,7 @@
           <a:bodyPr wrap="square" rtlCol="0" anchor="ctr"/>
           <a:lstStyle/>
           <a:p>
-            <a:pPr indent="0" marL="0">
+            <a:pPr marL="0" indent="0">
               <a:buNone/>
             </a:pPr>
             <a:r>
@@ -11178,7 +10794,7 @@
           <a:bodyPr wrap="square" rtlCol="0" anchor="ctr"/>
           <a:lstStyle/>
           <a:p>
-            <a:pPr indent="0" marL="0">
+            <a:pPr marL="0" indent="0">
               <a:buNone/>
             </a:pPr>
             <a:r>
@@ -11217,7 +10833,7 @@
           <a:bodyPr wrap="square" rtlCol="0" anchor="ctr"/>
           <a:lstStyle/>
           <a:p>
-            <a:pPr algn="r" indent="0" marL="0">
+            <a:pPr marL="0" indent="0" algn="r">
               <a:buNone/>
             </a:pPr>
             <a:r>
@@ -11256,7 +10872,7 @@
           <a:bodyPr wrap="square" rtlCol="0" anchor="ctr"/>
           <a:lstStyle/>
           <a:p>
-            <a:pPr algn="r" indent="0" marL="0">
+            <a:pPr marL="0" indent="0" algn="r">
               <a:buNone/>
             </a:pPr>
             <a:r>
@@ -11300,6 +10916,13 @@
             <a:prstDash val="solid"/>
           </a:ln>
         </p:spPr>
+        <p:txBody>
+          <a:bodyPr/>
+          <a:lstStyle/>
+          <a:p>
+            <a:endParaRPr lang="en-US"/>
+          </a:p>
+        </p:txBody>
       </p:sp>
       <p:sp>
         <p:nvSpPr>
@@ -11322,7 +10945,7 @@
           <a:bodyPr wrap="square" rtlCol="0" anchor="ctr"/>
           <a:lstStyle/>
           <a:p>
-            <a:pPr algn="ctr" indent="0" marL="0">
+            <a:pPr marL="0" indent="0" algn="ctr">
               <a:buNone/>
             </a:pPr>
             <a:r>
@@ -11361,7 +10984,7 @@
           <a:bodyPr wrap="square" rtlCol="0" anchor="ctr"/>
           <a:lstStyle/>
           <a:p>
-            <a:pPr indent="0" marL="0">
+            <a:pPr marL="0" indent="0">
               <a:buNone/>
             </a:pPr>
             <a:r>
@@ -11400,7 +11023,7 @@
           <a:bodyPr wrap="square" rtlCol="0" anchor="ctr"/>
           <a:lstStyle/>
           <a:p>
-            <a:pPr indent="0" marL="0">
+            <a:pPr marL="0" indent="0">
               <a:buNone/>
             </a:pPr>
             <a:r>
@@ -11439,7 +11062,7 @@
           <a:bodyPr wrap="square" rtlCol="0" anchor="ctr"/>
           <a:lstStyle/>
           <a:p>
-            <a:pPr algn="r" indent="0" marL="0">
+            <a:pPr marL="0" indent="0" algn="r">
               <a:buNone/>
             </a:pPr>
             <a:r>
@@ -11478,7 +11101,7 @@
           <a:bodyPr wrap="square" rtlCol="0" anchor="ctr"/>
           <a:lstStyle/>
           <a:p>
-            <a:pPr algn="r" indent="0" marL="0">
+            <a:pPr marL="0" indent="0" algn="r">
               <a:buNone/>
             </a:pPr>
             <a:r>
@@ -11522,6 +11145,13 @@
             <a:prstDash val="solid"/>
           </a:ln>
         </p:spPr>
+        <p:txBody>
+          <a:bodyPr/>
+          <a:lstStyle/>
+          <a:p>
+            <a:endParaRPr lang="en-US"/>
+          </a:p>
+        </p:txBody>
       </p:sp>
       <p:sp>
         <p:nvSpPr>
@@ -11544,7 +11174,7 @@
           <a:bodyPr wrap="square" rtlCol="0" anchor="ctr"/>
           <a:lstStyle/>
           <a:p>
-            <a:pPr algn="ctr" indent="0" marL="0">
+            <a:pPr marL="0" indent="0" algn="ctr">
               <a:buNone/>
             </a:pPr>
             <a:r>
@@ -11583,7 +11213,7 @@
           <a:bodyPr wrap="square" rtlCol="0" anchor="ctr"/>
           <a:lstStyle/>
           <a:p>
-            <a:pPr indent="0" marL="0">
+            <a:pPr marL="0" indent="0">
               <a:buNone/>
             </a:pPr>
             <a:r>
@@ -11622,7 +11252,7 @@
           <a:bodyPr wrap="square" rtlCol="0" anchor="ctr"/>
           <a:lstStyle/>
           <a:p>
-            <a:pPr indent="0" marL="0">
+            <a:pPr marL="0" indent="0">
               <a:buNone/>
             </a:pPr>
             <a:r>
@@ -11661,7 +11291,7 @@
           <a:bodyPr wrap="square" rtlCol="0" anchor="ctr"/>
           <a:lstStyle/>
           <a:p>
-            <a:pPr algn="r" indent="0" marL="0">
+            <a:pPr marL="0" indent="0" algn="r">
               <a:buNone/>
             </a:pPr>
             <a:r>
@@ -11700,7 +11330,7 @@
           <a:bodyPr wrap="square" rtlCol="0" anchor="ctr"/>
           <a:lstStyle/>
           <a:p>
-            <a:pPr algn="r" indent="0" marL="0">
+            <a:pPr marL="0" indent="0" algn="r">
               <a:buNone/>
             </a:pPr>
             <a:r>
@@ -11739,7 +11369,7 @@
           <a:bodyPr wrap="square" rtlCol="0" anchor="ctr"/>
           <a:lstStyle/>
           <a:p>
-            <a:pPr algn="ctr" indent="0" marL="0">
+            <a:pPr marL="0" indent="0" algn="ctr">
               <a:buNone/>
             </a:pPr>
             <a:r>
@@ -11773,6 +11403,7 @@
         <a:solidFill>
           <a:srgbClr val="FFFFFF"/>
         </a:solidFill>
+        <a:effectLst/>
       </p:bgPr>
     </p:bg>
     <p:spTree>
@@ -11810,7 +11441,7 @@
           <a:bodyPr wrap="square" rtlCol="0" anchor="ctr"/>
           <a:lstStyle/>
           <a:p>
-            <a:pPr indent="0" marL="0">
+            <a:pPr marL="0" indent="0">
               <a:buNone/>
             </a:pPr>
             <a:r>
@@ -11849,7 +11480,7 @@
           <a:bodyPr wrap="square" rtlCol="0" anchor="ctr"/>
           <a:lstStyle/>
           <a:p>
-            <a:pPr indent="0" marL="0">
+            <a:pPr marL="0" indent="0">
               <a:buNone/>
             </a:pPr>
             <a:r>
@@ -11888,7 +11519,7 @@
           <a:bodyPr wrap="square" rtlCol="0" anchor="ctr"/>
           <a:lstStyle/>
           <a:p>
-            <a:pPr algn="r" indent="0" marL="0">
+            <a:pPr marL="0" indent="0" algn="r">
               <a:buNone/>
             </a:pPr>
             <a:r>
@@ -11927,7 +11558,7 @@
           <a:bodyPr wrap="square" rtlCol="0" anchor="ctr"/>
           <a:lstStyle/>
           <a:p>
-            <a:pPr indent="0" marL="0">
+            <a:pPr marL="0" indent="0">
               <a:buNone/>
             </a:pPr>
             <a:r>
@@ -11971,6 +11602,13 @@
             <a:prstDash val="solid"/>
           </a:ln>
         </p:spPr>
+        <p:txBody>
+          <a:bodyPr/>
+          <a:lstStyle/>
+          <a:p>
+            <a:endParaRPr lang="en-US"/>
+          </a:p>
+        </p:txBody>
       </p:sp>
       <p:sp>
         <p:nvSpPr>
@@ -11993,7 +11631,7 @@
           <a:bodyPr wrap="square" rtlCol="0" anchor="ctr"/>
           <a:lstStyle/>
           <a:p>
-            <a:pPr algn="ctr" indent="0" marL="0">
+            <a:pPr marL="0" indent="0" algn="ctr">
               <a:buNone/>
             </a:pPr>
             <a:r>
@@ -12032,7 +11670,7 @@
           <a:bodyPr wrap="square" rtlCol="0" anchor="ctr"/>
           <a:lstStyle/>
           <a:p>
-            <a:pPr algn="ctr" indent="0" marL="0">
+            <a:pPr marL="0" indent="0" algn="ctr">
               <a:buNone/>
             </a:pPr>
             <a:r>
@@ -12049,7 +11687,7 @@
             <a:endParaRPr lang="en-US" sz="1100" dirty="0"/>
           </a:p>
           <a:p>
-            <a:pPr algn="ctr" indent="0" marL="0">
+            <a:pPr marL="0" indent="0" algn="ctr">
               <a:buNone/>
             </a:pPr>
             <a:r>
@@ -12093,6 +11731,13 @@
             <a:prstDash val="solid"/>
           </a:ln>
         </p:spPr>
+        <p:txBody>
+          <a:bodyPr/>
+          <a:lstStyle/>
+          <a:p>
+            <a:endParaRPr lang="en-US"/>
+          </a:p>
+        </p:txBody>
       </p:sp>
       <p:sp>
         <p:nvSpPr>
@@ -12115,7 +11760,7 @@
           <a:bodyPr wrap="square" rtlCol="0" anchor="ctr"/>
           <a:lstStyle/>
           <a:p>
-            <a:pPr algn="ctr" indent="0" marL="0">
+            <a:pPr marL="0" indent="0" algn="ctr">
               <a:buNone/>
             </a:pPr>
             <a:r>
@@ -12154,7 +11799,7 @@
           <a:bodyPr wrap="square" rtlCol="0" anchor="ctr"/>
           <a:lstStyle/>
           <a:p>
-            <a:pPr algn="ctr" indent="0" marL="0">
+            <a:pPr marL="0" indent="0" algn="ctr">
               <a:buNone/>
             </a:pPr>
             <a:r>
@@ -12171,7 +11816,7 @@
             <a:endParaRPr lang="en-US" sz="1100" dirty="0"/>
           </a:p>
           <a:p>
-            <a:pPr algn="ctr" indent="0" marL="0">
+            <a:pPr marL="0" indent="0" algn="ctr">
               <a:buNone/>
             </a:pPr>
             <a:r>
@@ -12215,6 +11860,13 @@
             <a:prstDash val="solid"/>
           </a:ln>
         </p:spPr>
+        <p:txBody>
+          <a:bodyPr/>
+          <a:lstStyle/>
+          <a:p>
+            <a:endParaRPr lang="en-US"/>
+          </a:p>
+        </p:txBody>
       </p:sp>
       <p:sp>
         <p:nvSpPr>
@@ -12237,7 +11889,7 @@
           <a:bodyPr wrap="square" rtlCol="0" anchor="ctr"/>
           <a:lstStyle/>
           <a:p>
-            <a:pPr algn="ctr" indent="0" marL="0">
+            <a:pPr marL="0" indent="0" algn="ctr">
               <a:buNone/>
             </a:pPr>
             <a:r>
@@ -12276,7 +11928,7 @@
           <a:bodyPr wrap="square" rtlCol="0" anchor="ctr"/>
           <a:lstStyle/>
           <a:p>
-            <a:pPr algn="ctr" indent="0" marL="0">
+            <a:pPr marL="0" indent="0" algn="ctr">
               <a:buNone/>
             </a:pPr>
             <a:r>
@@ -12293,7 +11945,7 @@
             <a:endParaRPr lang="en-US" sz="1100" dirty="0"/>
           </a:p>
           <a:p>
-            <a:pPr algn="ctr" indent="0" marL="0">
+            <a:pPr marL="0" indent="0" algn="ctr">
               <a:buNone/>
             </a:pPr>
             <a:r>
@@ -12337,6 +11989,13 @@
             <a:prstDash val="solid"/>
           </a:ln>
         </p:spPr>
+        <p:txBody>
+          <a:bodyPr/>
+          <a:lstStyle/>
+          <a:p>
+            <a:endParaRPr lang="en-US"/>
+          </a:p>
+        </p:txBody>
       </p:sp>
       <p:sp>
         <p:nvSpPr>
@@ -12359,7 +12018,7 @@
           <a:bodyPr wrap="square" rtlCol="0" anchor="ctr"/>
           <a:lstStyle/>
           <a:p>
-            <a:pPr algn="ctr" indent="0" marL="0">
+            <a:pPr marL="0" indent="0" algn="ctr">
               <a:buNone/>
             </a:pPr>
             <a:r>
@@ -12398,7 +12057,7 @@
           <a:bodyPr wrap="square" rtlCol="0" anchor="ctr"/>
           <a:lstStyle/>
           <a:p>
-            <a:pPr algn="ctr" indent="0" marL="0">
+            <a:pPr marL="0" indent="0" algn="ctr">
               <a:buNone/>
             </a:pPr>
             <a:r>
@@ -12415,7 +12074,7 @@
             <a:endParaRPr lang="en-US" sz="1100" dirty="0"/>
           </a:p>
           <a:p>
-            <a:pPr algn="ctr" indent="0" marL="0">
+            <a:pPr marL="0" indent="0" algn="ctr">
               <a:buNone/>
             </a:pPr>
             <a:r>
@@ -12459,6 +12118,13 @@
             <a:prstDash val="solid"/>
           </a:ln>
         </p:spPr>
+        <p:txBody>
+          <a:bodyPr/>
+          <a:lstStyle/>
+          <a:p>
+            <a:endParaRPr lang="en-US"/>
+          </a:p>
+        </p:txBody>
       </p:sp>
       <p:sp>
         <p:nvSpPr>
@@ -12481,7 +12147,7 @@
           <a:bodyPr wrap="square" rtlCol="0" anchor="ctr"/>
           <a:lstStyle/>
           <a:p>
-            <a:pPr indent="0" marL="0">
+            <a:pPr marL="0" indent="0">
               <a:buNone/>
             </a:pPr>
             <a:r>
@@ -12520,7 +12186,7 @@
           <a:bodyPr wrap="square" rtlCol="0" anchor="ctr"/>
           <a:lstStyle/>
           <a:p>
-            <a:pPr indent="0" marL="0">
+            <a:pPr marL="0" indent="0">
               <a:buNone/>
             </a:pPr>
             <a:r>
@@ -12535,9 +12201,6 @@
               <a:t>190,879 transactions, used once at the very end.
 </a:t>
             </a:r>
-            <a:pPr indent="0" marL="0">
-              <a:buNone/>
-            </a:pPr>
             <a:r>
               <a:rPr lang="en-US" sz="1300" dirty="0">
                 <a:solidFill>
@@ -12579,6 +12242,13 @@
             <a:prstDash val="solid"/>
           </a:ln>
         </p:spPr>
+        <p:txBody>
+          <a:bodyPr/>
+          <a:lstStyle/>
+          <a:p>
+            <a:endParaRPr lang="en-US"/>
+          </a:p>
+        </p:txBody>
       </p:sp>
       <p:sp>
         <p:nvSpPr>
@@ -12601,7 +12271,7 @@
           <a:bodyPr wrap="square" rtlCol="0" anchor="ctr"/>
           <a:lstStyle/>
           <a:p>
-            <a:pPr indent="0" marL="0">
+            <a:pPr marL="0" indent="0">
               <a:buNone/>
             </a:pPr>
             <a:r>
@@ -12640,7 +12310,7 @@
           <a:bodyPr wrap="square" rtlCol="0" anchor="ctr"/>
           <a:lstStyle/>
           <a:p>
-            <a:pPr indent="0" marL="0">
+            <a:pPr marL="0" indent="0">
               <a:buNone/>
             </a:pPr>
             <a:r>
@@ -12655,9 +12325,6 @@
               <a:t>Three methods agree on what drives the model: coefficients, tree importance and permutation importance.
 </a:t>
             </a:r>
-            <a:pPr indent="0" marL="0">
-              <a:buNone/>
-            </a:pPr>
             <a:r>
               <a:rPr lang="en-US" sz="1300" dirty="0">
                 <a:solidFill>
@@ -12974,4 +12641,319 @@
     </a:ext>
   </a:extLst>
 </a:theme>
+</file>
+
+<file path=ppt/theme/theme2.xml><?xml version="1.0" encoding="utf-8"?>
+<a:theme xmlns:a="http://schemas.openxmlformats.org/drawingml/2006/main" name="Office Theme">
+  <a:themeElements>
+    <a:clrScheme name="Office">
+      <a:dk1>
+        <a:sysClr val="windowText" lastClr="000000"/>
+      </a:dk1>
+      <a:lt1>
+        <a:sysClr val="window" lastClr="FFFFFF"/>
+      </a:lt1>
+      <a:dk2>
+        <a:srgbClr val="0E2841"/>
+      </a:dk2>
+      <a:lt2>
+        <a:srgbClr val="E8E8E8"/>
+      </a:lt2>
+      <a:accent1>
+        <a:srgbClr val="156082"/>
+      </a:accent1>
+      <a:accent2>
+        <a:srgbClr val="E97132"/>
+      </a:accent2>
+      <a:accent3>
+        <a:srgbClr val="196B24"/>
+      </a:accent3>
+      <a:accent4>
+        <a:srgbClr val="0F9ED5"/>
+      </a:accent4>
+      <a:accent5>
+        <a:srgbClr val="A02B93"/>
+      </a:accent5>
+      <a:accent6>
+        <a:srgbClr val="4EA72E"/>
+      </a:accent6>
+      <a:hlink>
+        <a:srgbClr val="467886"/>
+      </a:hlink>
+      <a:folHlink>
+        <a:srgbClr val="96607D"/>
+      </a:folHlink>
+    </a:clrScheme>
+    <a:fontScheme name="Office">
+      <a:majorFont>
+        <a:latin typeface="Aptos Display" panose="02110004020202020204"/>
+        <a:ea typeface=""/>
+        <a:cs typeface=""/>
+        <a:font script="Jpan" typeface="游ゴシック Light"/>
+        <a:font script="Hang" typeface="맑은 고딕"/>
+        <a:font script="Hans" typeface="等线 Light"/>
+        <a:font script="Hant" typeface="新細明體"/>
+        <a:font script="Arab" typeface="Times New Roman"/>
+        <a:font script="Hebr" typeface="Times New Roman"/>
+        <a:font script="Thai" typeface="Angsana New"/>
+        <a:font script="Ethi" typeface="Nyala"/>
+        <a:font script="Beng" typeface="Vrinda"/>
+        <a:font script="Gujr" typeface="Shruti"/>
+        <a:font script="Khmr" typeface="MoolBoran"/>
+        <a:font script="Knda" typeface="Tunga"/>
+        <a:font script="Guru" typeface="Raavi"/>
+        <a:font script="Cans" typeface="Euphemia"/>
+        <a:font script="Cher" typeface="Plantagenet Cherokee"/>
+        <a:font script="Yiii" typeface="Microsoft Yi Baiti"/>
+        <a:font script="Tibt" typeface="Microsoft Himalaya"/>
+        <a:font script="Thaa" typeface="MV Boli"/>
+        <a:font script="Deva" typeface="Mangal"/>
+        <a:font script="Telu" typeface="Gautami"/>
+        <a:font script="Taml" typeface="Latha"/>
+        <a:font script="Syrc" typeface="Estrangelo Edessa"/>
+        <a:font script="Orya" typeface="Kalinga"/>
+        <a:font script="Mlym" typeface="Kartika"/>
+        <a:font script="Laoo" typeface="DokChampa"/>
+        <a:font script="Sinh" typeface="Iskoola Pota"/>
+        <a:font script="Mong" typeface="Mongolian Baiti"/>
+        <a:font script="Viet" typeface="Times New Roman"/>
+        <a:font script="Uigh" typeface="Microsoft Uighur"/>
+        <a:font script="Geor" typeface="Sylfaen"/>
+        <a:font script="Armn" typeface="Arial"/>
+        <a:font script="Bugi" typeface="Leelawadee UI"/>
+        <a:font script="Bopo" typeface="Microsoft JhengHei"/>
+        <a:font script="Java" typeface="Javanese Text"/>
+        <a:font script="Lisu" typeface="Segoe UI"/>
+        <a:font script="Mymr" typeface="Myanmar Text"/>
+        <a:font script="Nkoo" typeface="Ebrima"/>
+        <a:font script="Olck" typeface="Nirmala UI"/>
+        <a:font script="Osma" typeface="Ebrima"/>
+        <a:font script="Phag" typeface="Phagspa"/>
+        <a:font script="Syrn" typeface="Estrangelo Edessa"/>
+        <a:font script="Syrj" typeface="Estrangelo Edessa"/>
+        <a:font script="Syre" typeface="Estrangelo Edessa"/>
+        <a:font script="Sora" typeface="Nirmala UI"/>
+        <a:font script="Tale" typeface="Microsoft Tai Le"/>
+        <a:font script="Talu" typeface="Microsoft New Tai Lue"/>
+        <a:font script="Tfng" typeface="Ebrima"/>
+      </a:majorFont>
+      <a:minorFont>
+        <a:latin typeface="Aptos" panose="02110004020202020204"/>
+        <a:ea typeface=""/>
+        <a:cs typeface=""/>
+        <a:font script="Jpan" typeface="游ゴシック"/>
+        <a:font script="Hang" typeface="맑은 고딕"/>
+        <a:font script="Hans" typeface="等线"/>
+        <a:font script="Hant" typeface="新細明體"/>
+        <a:font script="Arab" typeface="Arial"/>
+        <a:font script="Hebr" typeface="Arial"/>
+        <a:font script="Thai" typeface="Cordia New"/>
+        <a:font script="Ethi" typeface="Nyala"/>
+        <a:font script="Beng" typeface="Vrinda"/>
+        <a:font script="Gujr" typeface="Shruti"/>
+        <a:font script="Khmr" typeface="DaunPenh"/>
+        <a:font script="Knda" typeface="Tunga"/>
+        <a:font script="Guru" typeface="Raavi"/>
+        <a:font script="Cans" typeface="Euphemia"/>
+        <a:font script="Cher" typeface="Plantagenet Cherokee"/>
+        <a:font script="Yiii" typeface="Microsoft Yi Baiti"/>
+        <a:font script="Tibt" typeface="Microsoft Himalaya"/>
+        <a:font script="Thaa" typeface="MV Boli"/>
+        <a:font script="Deva" typeface="Mangal"/>
+        <a:font script="Telu" typeface="Gautami"/>
+        <a:font script="Taml" typeface="Latha"/>
+        <a:font script="Syrc" typeface="Estrangelo Edessa"/>
+        <a:font script="Orya" typeface="Kalinga"/>
+        <a:font script="Mlym" typeface="Kartika"/>
+        <a:font script="Laoo" typeface="DokChampa"/>
+        <a:font script="Sinh" typeface="Iskoola Pota"/>
+        <a:font script="Mong" typeface="Mongolian Baiti"/>
+        <a:font script="Viet" typeface="Arial"/>
+        <a:font script="Uigh" typeface="Microsoft Uighur"/>
+        <a:font script="Geor" typeface="Sylfaen"/>
+        <a:font script="Armn" typeface="Arial"/>
+        <a:font script="Bugi" typeface="Leelawadee UI"/>
+        <a:font script="Bopo" typeface="Microsoft JhengHei"/>
+        <a:font script="Java" typeface="Javanese Text"/>
+        <a:font script="Lisu" typeface="Segoe UI"/>
+        <a:font script="Mymr" typeface="Myanmar Text"/>
+        <a:font script="Nkoo" typeface="Ebrima"/>
+        <a:font script="Olck" typeface="Nirmala UI"/>
+        <a:font script="Osma" typeface="Ebrima"/>
+        <a:font script="Phag" typeface="Phagspa"/>
+        <a:font script="Syrn" typeface="Estrangelo Edessa"/>
+        <a:font script="Syrj" typeface="Estrangelo Edessa"/>
+        <a:font script="Syre" typeface="Estrangelo Edessa"/>
+        <a:font script="Sora" typeface="Nirmala UI"/>
+        <a:font script="Tale" typeface="Microsoft Tai Le"/>
+        <a:font script="Talu" typeface="Microsoft New Tai Lue"/>
+        <a:font script="Tfng" typeface="Ebrima"/>
+      </a:minorFont>
+    </a:fontScheme>
+    <a:fmtScheme name="Office">
+      <a:fillStyleLst>
+        <a:solidFill>
+          <a:schemeClr val="phClr"/>
+        </a:solidFill>
+        <a:gradFill rotWithShape="1">
+          <a:gsLst>
+            <a:gs pos="0">
+              <a:schemeClr val="phClr">
+                <a:lumMod val="110000"/>
+                <a:satMod val="105000"/>
+                <a:tint val="67000"/>
+              </a:schemeClr>
+            </a:gs>
+            <a:gs pos="50000">
+              <a:schemeClr val="phClr">
+                <a:lumMod val="105000"/>
+                <a:satMod val="103000"/>
+                <a:tint val="73000"/>
+              </a:schemeClr>
+            </a:gs>
+            <a:gs pos="100000">
+              <a:schemeClr val="phClr">
+                <a:lumMod val="105000"/>
+                <a:satMod val="109000"/>
+                <a:tint val="81000"/>
+              </a:schemeClr>
+            </a:gs>
+          </a:gsLst>
+          <a:lin ang="5400000" scaled="0"/>
+        </a:gradFill>
+        <a:gradFill rotWithShape="1">
+          <a:gsLst>
+            <a:gs pos="0">
+              <a:schemeClr val="phClr">
+                <a:satMod val="103000"/>
+                <a:lumMod val="102000"/>
+                <a:tint val="94000"/>
+              </a:schemeClr>
+            </a:gs>
+            <a:gs pos="50000">
+              <a:schemeClr val="phClr">
+                <a:satMod val="110000"/>
+                <a:lumMod val="100000"/>
+                <a:shade val="100000"/>
+              </a:schemeClr>
+            </a:gs>
+            <a:gs pos="100000">
+              <a:schemeClr val="phClr">
+                <a:lumMod val="99000"/>
+                <a:satMod val="120000"/>
+                <a:shade val="78000"/>
+              </a:schemeClr>
+            </a:gs>
+          </a:gsLst>
+          <a:lin ang="5400000" scaled="0"/>
+        </a:gradFill>
+      </a:fillStyleLst>
+      <a:lnStyleLst>
+        <a:ln w="12700" cap="flat" cmpd="sng" algn="ctr">
+          <a:solidFill>
+            <a:schemeClr val="phClr"/>
+          </a:solidFill>
+          <a:prstDash val="solid"/>
+          <a:miter lim="800000"/>
+        </a:ln>
+        <a:ln w="19050" cap="flat" cmpd="sng" algn="ctr">
+          <a:solidFill>
+            <a:schemeClr val="phClr"/>
+          </a:solidFill>
+          <a:prstDash val="solid"/>
+          <a:miter lim="800000"/>
+        </a:ln>
+        <a:ln w="25400" cap="flat" cmpd="sng" algn="ctr">
+          <a:solidFill>
+            <a:schemeClr val="phClr"/>
+          </a:solidFill>
+          <a:prstDash val="solid"/>
+          <a:miter lim="800000"/>
+        </a:ln>
+      </a:lnStyleLst>
+      <a:effectStyleLst>
+        <a:effectStyle>
+          <a:effectLst/>
+        </a:effectStyle>
+        <a:effectStyle>
+          <a:effectLst/>
+        </a:effectStyle>
+        <a:effectStyle>
+          <a:effectLst>
+            <a:outerShdw blurRad="57150" dist="19050" dir="5400000" algn="ctr" rotWithShape="0">
+              <a:srgbClr val="000000">
+                <a:alpha val="63000"/>
+              </a:srgbClr>
+            </a:outerShdw>
+          </a:effectLst>
+        </a:effectStyle>
+      </a:effectStyleLst>
+      <a:bgFillStyleLst>
+        <a:solidFill>
+          <a:schemeClr val="phClr"/>
+        </a:solidFill>
+        <a:solidFill>
+          <a:schemeClr val="phClr">
+            <a:tint val="95000"/>
+            <a:satMod val="170000"/>
+          </a:schemeClr>
+        </a:solidFill>
+        <a:gradFill rotWithShape="1">
+          <a:gsLst>
+            <a:gs pos="0">
+              <a:schemeClr val="phClr">
+                <a:tint val="93000"/>
+                <a:satMod val="150000"/>
+                <a:shade val="98000"/>
+                <a:lumMod val="102000"/>
+              </a:schemeClr>
+            </a:gs>
+            <a:gs pos="50000">
+              <a:schemeClr val="phClr">
+                <a:tint val="98000"/>
+                <a:satMod val="130000"/>
+                <a:shade val="90000"/>
+                <a:lumMod val="103000"/>
+              </a:schemeClr>
+            </a:gs>
+            <a:gs pos="100000">
+              <a:schemeClr val="phClr">
+                <a:shade val="63000"/>
+                <a:satMod val="120000"/>
+              </a:schemeClr>
+            </a:gs>
+          </a:gsLst>
+          <a:lin ang="5400000" scaled="0"/>
+        </a:gradFill>
+      </a:bgFillStyleLst>
+    </a:fmtScheme>
+  </a:themeElements>
+  <a:objectDefaults>
+    <a:lnDef>
+      <a:spPr/>
+      <a:bodyPr/>
+      <a:lstStyle/>
+      <a:style>
+        <a:lnRef idx="2">
+          <a:schemeClr val="accent1"/>
+        </a:lnRef>
+        <a:fillRef idx="0">
+          <a:schemeClr val="accent1"/>
+        </a:fillRef>
+        <a:effectRef idx="1">
+          <a:schemeClr val="accent1"/>
+        </a:effectRef>
+        <a:fontRef idx="minor">
+          <a:schemeClr val="tx1"/>
+        </a:fontRef>
+      </a:style>
+    </a:lnDef>
+  </a:objectDefaults>
+  <a:extraClrSchemeLst/>
+  <a:extLst>
+    <a:ext uri="{05A4C25C-085E-4340-85A3-A5531E510DB2}">
+      <thm15:themeFamily xmlns:thm15="http://schemas.microsoft.com/office/thememl/2012/main" name="Office Theme" id="{2E142A2C-CD16-42D6-873A-C26D2A0506FA}" vid="{1BDDFF52-6CD6-40A5-AB3C-68EB2F1E4D0A}"/>
+    </a:ext>
+  </a:extLst>
+</a:theme>
 </file>
</xml_diff>